<commit_message>
Fix approval and invoice UX found in the end-to-end check
- Approve Timesheets: Approve / Reject buttons in the header of the opened
  timesheet (before only above the table, greyed until a row was ticked);
  list shows Submitted by default and keeps approved / rejected timesheets
  with a coloured status; actions enabled only for Submitted
- Billing Workbench: generateInvoice is bound to the invoice list, so Fiori
  opens the new invoice and reloads the list (unbound action left it stale)
- New test for the approval list; docs, PDFs and slides updated (42 tests)
</commit_message>
<xml_diff>
--- a/docs/PSA_Project_Overview.pptx
+++ b/docs/PSA_Project_Overview.pptx
@@ -116,20 +116,20 @@
   <p:extLst>
     <p:ext uri="{521415D9-36F7-43E2-AB2F-B90AF26B5E84}">
       <p14:sectionLst xmlns:p14="http://schemas.microsoft.com/office/powerpoint/2010/main">
-        <p14:section name="Overview" id="{b0b4eb9a-7aec-e64b-7894-eb1d7d4a0e70}">
+        <p14:section name="Overview" id="{e3e85d03-e1aa-1b17-d46d-8883bafdcb1f}">
           <p14:sldIdLst>
             <p14:sldId id="256"/>
             <p14:sldId id="257"/>
           </p14:sldIdLst>
         </p14:section>
-        <p14:section name="Solution" id="{1d7414d8-6b91-6547-577d-878a9c402130}">
+        <p14:section name="Solution" id="{16ca47c7-ac9d-dd29-e9d8-8143dd69399b}">
           <p14:sldIdLst>
             <p14:sldId id="258"/>
             <p14:sldId id="259"/>
             <p14:sldId id="260"/>
           </p14:sldIdLst>
         </p14:section>
-        <p14:section name="Apps" id="{1f02f212-cf41-8a53-89a0-899624a29a7c}">
+        <p14:section name="Apps" id="{96a91fd9-3c89-a221-fefb-113ccfe91540}">
           <p14:sldIdLst>
             <p14:sldId id="261"/>
             <p14:sldId id="262"/>
@@ -137,7 +137,7 @@
             <p14:sldId id="264"/>
           </p14:sldIdLst>
         </p14:section>
-        <p14:section name="Delivery" id="{46adbb23-3d47-a138-ef65-b31e9ba32fa9}">
+        <p14:section name="Delivery" id="{baef3f18-c98a-c55b-5e66-034662e8e0e3}">
           <p14:sldIdLst>
             <p14:sldId id="265"/>
           </p14:sldIdLst>
@@ -3217,7 +3217,7 @@
                   <a:schemeClr val="accent5"/>
                 </a:solidFill>
               </a:rPr>
-              <a:t>41 tests</a:t>
+              <a:t>42 tests</a:t>
             </a:r>
             <a:endParaRPr lang="en-US" sz="1100" dirty="0"/>
           </a:p>
@@ -5217,7 +5217,7 @@
                   <a:schemeClr val="accent1"/>
                 </a:solidFill>
               </a:rPr>
-              <a:t>41</a:t>
+              <a:t>42</a:t>
             </a:r>
             <a:endParaRPr lang="en-US" sz="4400" dirty="0"/>
           </a:p>
@@ -8188,7 +8188,7 @@
                   <a:schemeClr val="tx2"/>
                 </a:solidFill>
               </a:rPr>
-              <a:t>Admin: bulk Approve · Reject with reason</a:t>
+              <a:t>Admin: Approve / Reject in the header or the list</a:t>
             </a:r>
             <a:endParaRPr lang="en-US" sz="1100" dirty="0"/>
           </a:p>

</xml_diff>

<commit_message>
Slides: one large high-resolution screenshot per app with highlights
</commit_message>
<xml_diff>
--- a/docs/PSA_Project_Overview.pptx
+++ b/docs/PSA_Project_Overview.pptx
@@ -15,9 +15,11 @@
     <p:sldId id="263" r:id="rId9"/>
     <p:sldId id="264" r:id="rId10"/>
     <p:sldId id="265" r:id="rId11"/>
+    <p:sldId id="266" r:id="rId12"/>
+    <p:sldId id="267" r:id="rId13"/>
   </p:sldIdLst>
   <p:notesMasterIdLst>
-    <p:notesMasterId r:id="rId12"/>
+    <p:notesMasterId r:id="rId14"/>
   </p:notesMasterIdLst>
   <p:sldSz cx="9144000" cy="5143500"/>
   <p:notesSz cx="5143500" cy="9144000"/>
@@ -116,30 +118,32 @@
   <p:extLst>
     <p:ext uri="{521415D9-36F7-43E2-AB2F-B90AF26B5E84}">
       <p14:sectionLst xmlns:p14="http://schemas.microsoft.com/office/powerpoint/2010/main">
-        <p14:section name="Overview" id="{e3e85d03-e1aa-1b17-d46d-8883bafdcb1f}">
+        <p14:section name="Overview" id="{3f036819-7c25-0bb8-46df-ec839bf14553}">
           <p14:sldIdLst>
             <p14:sldId id="256"/>
             <p14:sldId id="257"/>
           </p14:sldIdLst>
         </p14:section>
-        <p14:section name="Solution" id="{16ca47c7-ac9d-dd29-e9d8-8143dd69399b}">
+        <p14:section name="Solution" id="{6a6d951e-049c-fa1a-00cf-45d2de8ce90a}">
           <p14:sldIdLst>
             <p14:sldId id="258"/>
             <p14:sldId id="259"/>
             <p14:sldId id="260"/>
           </p14:sldIdLst>
         </p14:section>
-        <p14:section name="Apps" id="{96a91fd9-3c89-a221-fefb-113ccfe91540}">
+        <p14:section name="Apps" id="{fb89eebb-0141-ac8e-eefe-4e882fe1124e}">
           <p14:sldIdLst>
             <p14:sldId id="261"/>
             <p14:sldId id="262"/>
             <p14:sldId id="263"/>
             <p14:sldId id="264"/>
+            <p14:sldId id="265"/>
+            <p14:sldId id="266"/>
           </p14:sldIdLst>
         </p14:section>
-        <p14:section name="Delivery" id="{baef3f18-c98a-c55b-5e66-034662e8e0e3}">
+        <p14:section name="Delivery" id="{f9d8bd25-64b9-0d2f-f536-f9c583d72685}">
           <p14:sldIdLst>
-            <p14:sldId id="265"/>
+            <p14:sldId id="267"/>
           </p14:sldIdLst>
         </p14:section>
       </p14:sectionLst>
@@ -658,6 +662,182 @@
             <a:fld id="{F7021451-1387-4CA6-816F-3879F97B5CBC}" type="slidenum">
               <a:rPr lang="en-US"/>
               <a:t>10</a:t>
+            </a:fld>
+            <a:endParaRPr lang="en-US"/>
+          </a:p>
+        </p:txBody>
+      </p:sp>
+    </p:spTree>
+    <p:extLst>
+      <p:ext uri="{BB962C8B-B14F-4D97-AF65-F5344CB8AC3E}">
+        <p14:creationId xmlns:p14="http://schemas.microsoft.com/office/powerpoint/2010/main" val="1024086991"/>
+      </p:ext>
+    </p:extLst>
+  </p:cSld>
+  <p:clrMapOvr>
+    <a:masterClrMapping/>
+  </p:clrMapOvr>
+</p:notes>
+</file>
+
+<file path=ppt/notesSlides/notesSlide11.xml><?xml version="1.0" encoding="utf-8"?>
+<p:notes xmlns:a="http://schemas.openxmlformats.org/drawingml/2006/main" xmlns:r="http://schemas.openxmlformats.org/officeDocument/2006/relationships" xmlns:p="http://schemas.openxmlformats.org/presentationml/2006/main">
+  <p:cSld>
+    <p:spTree>
+      <p:nvGrpSpPr>
+        <p:cNvPr id="1" name=""/>
+        <p:cNvGrpSpPr/>
+        <p:nvPr/>
+      </p:nvGrpSpPr>
+      <p:grpSpPr>
+        <a:xfrm>
+          <a:off x="0" y="0"/>
+          <a:ext cx="0" cy="0"/>
+          <a:chOff x="0" y="0"/>
+          <a:chExt cx="0" cy="0"/>
+        </a:xfrm>
+      </p:grpSpPr>
+      <p:sp>
+        <p:nvSpPr>
+          <p:cNvPr id="2" name="Slide Image Placeholder 1"/>
+          <p:cNvSpPr>
+            <a:spLocks noGrp="1" noRot="1" noChangeAspect="1"/>
+          </p:cNvSpPr>
+          <p:nvPr>
+            <p:ph type="sldImg"/>
+          </p:nvPr>
+        </p:nvSpPr>
+        <p:spPr/>
+      </p:sp>
+      <p:sp>
+        <p:nvSpPr>
+          <p:cNvPr id="3" name="Notes Placeholder 2"/>
+          <p:cNvSpPr>
+            <a:spLocks noGrp="1"/>
+          </p:cNvSpPr>
+          <p:nvPr>
+            <p:ph type="body" idx="1"/>
+          </p:nvPr>
+        </p:nvSpPr>
+        <p:spPr/>
+        <p:txBody>
+          <a:bodyPr/>
+          <a:lstStyle/>
+          <a:p>
+            <a:r>
+              <a:rPr lang="en-US" dirty="0"/>
+              <a:t/>
+            </a:r>
+            <a:endParaRPr lang="en-US" dirty="0"/>
+          </a:p>
+        </p:txBody>
+      </p:sp>
+      <p:sp>
+        <p:nvSpPr>
+          <p:cNvPr id="4" name="Slide Number Placeholder 3"/>
+          <p:cNvSpPr>
+            <a:spLocks noGrp="1"/>
+          </p:cNvSpPr>
+          <p:nvPr>
+            <p:ph type="sldNum" sz="quarter" idx="10"/>
+          </p:nvPr>
+        </p:nvSpPr>
+        <p:spPr/>
+        <p:txBody>
+          <a:bodyPr/>
+          <a:lstStyle/>
+          <a:p>
+            <a:fld id="{F7021451-1387-4CA6-816F-3879F97B5CBC}" type="slidenum">
+              <a:rPr lang="en-US"/>
+              <a:t>11</a:t>
+            </a:fld>
+            <a:endParaRPr lang="en-US"/>
+          </a:p>
+        </p:txBody>
+      </p:sp>
+    </p:spTree>
+    <p:extLst>
+      <p:ext uri="{BB962C8B-B14F-4D97-AF65-F5344CB8AC3E}">
+        <p14:creationId xmlns:p14="http://schemas.microsoft.com/office/powerpoint/2010/main" val="1024086991"/>
+      </p:ext>
+    </p:extLst>
+  </p:cSld>
+  <p:clrMapOvr>
+    <a:masterClrMapping/>
+  </p:clrMapOvr>
+</p:notes>
+</file>
+
+<file path=ppt/notesSlides/notesSlide12.xml><?xml version="1.0" encoding="utf-8"?>
+<p:notes xmlns:a="http://schemas.openxmlformats.org/drawingml/2006/main" xmlns:r="http://schemas.openxmlformats.org/officeDocument/2006/relationships" xmlns:p="http://schemas.openxmlformats.org/presentationml/2006/main">
+  <p:cSld>
+    <p:spTree>
+      <p:nvGrpSpPr>
+        <p:cNvPr id="1" name=""/>
+        <p:cNvGrpSpPr/>
+        <p:nvPr/>
+      </p:nvGrpSpPr>
+      <p:grpSpPr>
+        <a:xfrm>
+          <a:off x="0" y="0"/>
+          <a:ext cx="0" cy="0"/>
+          <a:chOff x="0" y="0"/>
+          <a:chExt cx="0" cy="0"/>
+        </a:xfrm>
+      </p:grpSpPr>
+      <p:sp>
+        <p:nvSpPr>
+          <p:cNvPr id="2" name="Slide Image Placeholder 1"/>
+          <p:cNvSpPr>
+            <a:spLocks noGrp="1" noRot="1" noChangeAspect="1"/>
+          </p:cNvSpPr>
+          <p:nvPr>
+            <p:ph type="sldImg"/>
+          </p:nvPr>
+        </p:nvSpPr>
+        <p:spPr/>
+      </p:sp>
+      <p:sp>
+        <p:nvSpPr>
+          <p:cNvPr id="3" name="Notes Placeholder 2"/>
+          <p:cNvSpPr>
+            <a:spLocks noGrp="1"/>
+          </p:cNvSpPr>
+          <p:nvPr>
+            <p:ph type="body" idx="1"/>
+          </p:nvPr>
+        </p:nvSpPr>
+        <p:spPr/>
+        <p:txBody>
+          <a:bodyPr/>
+          <a:lstStyle/>
+          <a:p>
+            <a:r>
+              <a:rPr lang="en-US" dirty="0"/>
+              <a:t/>
+            </a:r>
+            <a:endParaRPr lang="en-US" dirty="0"/>
+          </a:p>
+        </p:txBody>
+      </p:sp>
+      <p:sp>
+        <p:nvSpPr>
+          <p:cNvPr id="4" name="Slide Number Placeholder 3"/>
+          <p:cNvSpPr>
+            <a:spLocks noGrp="1"/>
+          </p:cNvSpPr>
+          <p:nvPr>
+            <p:ph type="sldNum" sz="quarter" idx="10"/>
+          </p:nvPr>
+        </p:nvSpPr>
+        <p:spPr/>
+        <p:txBody>
+          <a:bodyPr/>
+          <a:lstStyle/>
+          <a:p>
+            <a:fld id="{F7021451-1387-4CA6-816F-3879F97B5CBC}" type="slidenum">
+              <a:rPr lang="en-US"/>
+              <a:t>12</a:t>
             </a:fld>
             <a:endParaRPr lang="en-US"/>
           </a:p>
@@ -2540,8 +2720,8 @@
         </p:nvSpPr>
         <p:spPr>
           <a:xfrm>
-            <a:off x="4983480" y="960120"/>
-            <a:ext cx="3749040" cy="2249424"/>
+            <a:off x="4937760" y="960120"/>
+            <a:ext cx="3794760" cy="2176272"/>
           </a:xfrm>
           <a:prstGeom prst="rect">
             <a:avLst/>
@@ -2580,8 +2760,8 @@
         </p:blipFill>
         <p:spPr>
           <a:xfrm>
-            <a:off x="5010912" y="987552"/>
-            <a:ext cx="3694176" cy="2194560"/>
+            <a:off x="4965192" y="987552"/>
+            <a:ext cx="3739896" cy="2121408"/>
           </a:xfrm>
           <a:prstGeom prst="rect">
             <a:avLst/>
@@ -2596,8 +2776,8 @@
         </p:nvSpPr>
         <p:spPr>
           <a:xfrm>
-            <a:off x="4983480" y="3310128"/>
-            <a:ext cx="3749040" cy="274320"/>
+            <a:off x="4937760" y="3246120"/>
+            <a:ext cx="3794760" cy="274320"/>
           </a:xfrm>
           <a:prstGeom prst="rect">
             <a:avLst/>
@@ -2678,10 +2858,10 @@
             <a:r>
               <a:rPr lang="en-US" sz="3000" b="1" dirty="0">
                 <a:solidFill>
-                  <a:schemeClr val="bg1"/>
-                </a:solidFill>
-              </a:rPr>
-              <a:t>Delivery and CI/CD</a:t>
+                  <a:schemeClr val="tx1"/>
+                </a:solidFill>
+              </a:rPr>
+              <a:t>Billing Workbench</a:t>
             </a:r>
             <a:endParaRPr lang="en-US" sz="3000" dirty="0"/>
           </a:p>
@@ -2689,27 +2869,39 @@
       </p:sp>
       <p:sp>
         <p:nvSpPr>
-          <p:cNvPr id="3" name="Push / merge icon circle"/>
+          <p:cNvPr id="3" name="Billing Workbench screenshot frame"/>
           <p:cNvSpPr/>
           <p:nvPr/>
         </p:nvSpPr>
         <p:spPr>
           <a:xfrm>
-            <a:off x="822960" y="1143000"/>
-            <a:ext cx="731520" cy="731520"/>
-          </a:xfrm>
-          <a:prstGeom prst="ellipse">
+            <a:off x="457200" y="1051560"/>
+            <a:ext cx="6309360" cy="3611880"/>
+          </a:xfrm>
+          <a:prstGeom prst="rect">
             <a:avLst/>
           </a:prstGeom>
           <a:solidFill>
-            <a:schemeClr val="accent1"/>
+            <a:schemeClr val="bg1"/>
           </a:solidFill>
-          <a:ln/>
+          <a:ln w="12700">
+            <a:solidFill>
+              <a:schemeClr val="bg2"/>
+            </a:solidFill>
+            <a:prstDash val="solid"/>
+          </a:ln>
+          <a:effectLst>
+            <a:outerShdw sx="100000" sy="100000" kx="0" ky="0" algn="bl" rotWithShape="0" blurRad="101600" dist="25400" dir="5400000">
+              <a:srgbClr val="000000">
+                <a:alpha val="22000"/>
+              </a:srgbClr>
+            </a:outerShdw>
+          </a:effectLst>
         </p:spPr>
       </p:sp>
       <p:pic>
         <p:nvPicPr>
-          <p:cNvPr id="4" name="Push / merge icon" descr="Push / merge icon">    </p:cNvPr>
+          <p:cNvPr id="4" name="Billing Workbench screenshot" descr="Billing Workbench screenshot">    </p:cNvPr>
           <p:cNvPicPr>
             <a:picLocks noChangeAspect="1"/>
           </p:cNvPicPr>
@@ -2723,6 +2915,701 @@
         </p:blipFill>
         <p:spPr>
           <a:xfrm>
+            <a:off x="484632" y="1078992"/>
+            <a:ext cx="6254496" cy="3557016"/>
+          </a:xfrm>
+          <a:prstGeom prst="rect">
+            <a:avLst/>
+          </a:prstGeom>
+        </p:spPr>
+      </p:pic>
+      <p:sp>
+        <p:nvSpPr>
+          <p:cNvPr id="5" name="highlight amount and status"/>
+          <p:cNvSpPr/>
+          <p:nvPr/>
+        </p:nvSpPr>
+        <p:spPr>
+          <a:xfrm>
+            <a:off x="3083284" y="1771635"/>
+            <a:ext cx="1749357" cy="330036"/>
+          </a:xfrm>
+          <a:prstGeom prst="roundRect">
+            <a:avLst>
+              <a:gd name="adj" fmla="val 16624"/>
+            </a:avLst>
+          </a:prstGeom>
+          <a:solidFill>
+            <a:schemeClr val="bg1">
+              <a:alpha val="0"/>
+            </a:schemeClr>
+          </a:solidFill>
+          <a:ln w="31750">
+            <a:solidFill>
+              <a:schemeClr val="accent2"/>
+            </a:solidFill>
+            <a:prstDash val="solid"/>
+          </a:ln>
+        </p:spPr>
+      </p:sp>
+      <p:sp>
+        <p:nvSpPr>
+          <p:cNvPr id="6" name="Text 3"/>
+          <p:cNvSpPr txBox="1"/>
+          <p:nvPr/>
+        </p:nvSpPr>
+        <p:spPr>
+          <a:xfrm>
+            <a:off x="6995160" y="1051560"/>
+            <a:ext cx="1691640" cy="548640"/>
+          </a:xfrm>
+          <a:prstGeom prst="rect">
+            <a:avLst/>
+          </a:prstGeom>
+          <a:noFill/>
+          <a:ln/>
+        </p:spPr>
+        <p:txBody>
+          <a:bodyPr wrap="square" lIns="0" tIns="0" rIns="0" bIns="0" rtlCol="0" anchor="t"/>
+          <a:lstStyle/>
+          <a:p>
+            <a:pPr indent="0" marL="0">
+              <a:buNone/>
+            </a:pPr>
+            <a:r>
+              <a:rPr lang="en-US" sz="1400" b="1" dirty="0">
+                <a:solidFill>
+                  <a:schemeClr val="accent1"/>
+                </a:solidFill>
+              </a:rPr>
+              <a:t>Draft → Issued → Paid</a:t>
+            </a:r>
+            <a:endParaRPr lang="en-US" sz="1400" dirty="0"/>
+          </a:p>
+        </p:txBody>
+      </p:sp>
+      <p:sp>
+        <p:nvSpPr>
+          <p:cNvPr id="7" name="Text 4"/>
+          <p:cNvSpPr txBox="1"/>
+          <p:nvPr/>
+        </p:nvSpPr>
+        <p:spPr>
+          <a:xfrm>
+            <a:off x="6995160" y="1645920"/>
+            <a:ext cx="1691640" cy="3017520"/>
+          </a:xfrm>
+          <a:prstGeom prst="rect">
+            <a:avLst/>
+          </a:prstGeom>
+          <a:noFill/>
+          <a:ln/>
+        </p:spPr>
+        <p:txBody>
+          <a:bodyPr wrap="square" lIns="0" tIns="0" rIns="0" bIns="0" rtlCol="0" anchor="t"/>
+          <a:lstStyle/>
+          <a:p>
+            <a:pPr marL="177800" indent="-177800">
+              <a:spcAft>
+                <a:spcPts val="800"/>
+              </a:spcAft>
+              <a:buSzPct val="100000"/>
+              <a:buChar char="•"/>
+            </a:pPr>
+            <a:r>
+              <a:rPr lang="en-US" sz="1200" dirty="0">
+                <a:solidFill>
+                  <a:schemeClr val="tx1"/>
+                </a:solidFill>
+              </a:rPr>
+              <a:t>Invoice from approved billable hours</a:t>
+            </a:r>
+            <a:endParaRPr lang="en-US" sz="1200" dirty="0"/>
+          </a:p>
+          <a:p>
+            <a:pPr marL="177800" indent="-177800">
+              <a:spcAft>
+                <a:spcPts val="800"/>
+              </a:spcAft>
+              <a:buSzPct val="100000"/>
+              <a:buChar char="•"/>
+            </a:pPr>
+            <a:r>
+              <a:rPr lang="en-US" sz="1200" dirty="0">
+                <a:solidFill>
+                  <a:schemeClr val="tx1"/>
+                </a:solidFill>
+              </a:rPr>
+              <a:t>T&amp;M · Fixed (capped) · Retainer</a:t>
+            </a:r>
+            <a:endParaRPr lang="en-US" sz="1200" dirty="0"/>
+          </a:p>
+          <a:p>
+            <a:pPr marL="177800" indent="-177800">
+              <a:spcAft>
+                <a:spcPts val="800"/>
+              </a:spcAft>
+              <a:buSzPct val="100000"/>
+              <a:buChar char="•"/>
+            </a:pPr>
+            <a:r>
+              <a:rPr lang="en-US" sz="1200" dirty="0">
+                <a:solidFill>
+                  <a:schemeClr val="tx1"/>
+                </a:solidFill>
+              </a:rPr>
+              <a:t>Tax and due date from Settings</a:t>
+            </a:r>
+            <a:endParaRPr lang="en-US" sz="1200" dirty="0"/>
+          </a:p>
+          <a:p>
+            <a:pPr marL="177800" indent="-177800">
+              <a:spcAft>
+                <a:spcPts val="800"/>
+              </a:spcAft>
+              <a:buSzPct val="100000"/>
+              <a:buChar char="•"/>
+            </a:pPr>
+            <a:r>
+              <a:rPr lang="en-US" sz="1200" dirty="0">
+                <a:solidFill>
+                  <a:schemeClr val="tx1"/>
+                </a:solidFill>
+              </a:rPr>
+              <a:t>Cancel → hours billable again</a:t>
+            </a:r>
+            <a:endParaRPr lang="en-US" sz="1200" dirty="0"/>
+          </a:p>
+        </p:txBody>
+      </p:sp>
+      <p:sp>
+        <p:nvSpPr>
+          <p:cNvPr id="25" name="Slide Number Placeholder 0"/>
+          <p:cNvSpPr>
+            <a:spLocks noGrp="1"/>
+          </p:cNvSpPr>
+          <p:nvPr>
+            <p:ph type="sldNum" sz="quarter" idx="4294967295"/>
+          </p:nvPr>
+        </p:nvSpPr>
+        <p:spPr>
+          <a:xfrm>
+            <a:off x="8229600" y="4800600"/>
+            <a:ext cx="457200" cy="228600"/>
+          </a:xfrm>
+          <a:prstGeom prst="rect">
+            <a:avLst/>
+          </a:prstGeom>
+          <a:extLst>
+            <a:ext uri="{C572A759-6A51-4108-AA02-DFA0A04FC94B}">
+              <ma14:wrappingTextBoxFlag xmlns:ma14="http://schemas.microsoft.com/office/mac/drawingml/2011/main" val="0"/>
+            </a:ext>
+          </a:extLst>
+        </p:spPr>
+        <p:txBody>
+          <a:bodyPr/>
+          <a:lstStyle>
+            <a:lvl1pPr>
+              <a:defRPr sz="900">
+                <a:solidFill>
+                  <a:schemeClr val="tx2"/>
+                </a:solidFill>
+              </a:defRPr>
+            </a:lvl1pPr>
+          </a:lstStyle>
+          <a:p>
+            <a:pPr algn="r"/>
+            <a:fld id="{F7021451-1387-4CA6-816F-3879F97B5CBC}" type="slidenum">
+              <a:rPr b="0" lang="en-US"/>
+              <a:t>10</a:t>
+            </a:fld>
+            <a:endParaRPr lang="en-US"/>
+          </a:p>
+        </p:txBody>
+      </p:sp>
+    </p:spTree>
+  </p:cSld>
+  <p:clrMapOvr>
+    <a:masterClrMapping/>
+  </p:clrMapOvr>
+</p:sld>
+</file>
+
+<file path=ppt/slides/slide11.xml><?xml version="1.0" encoding="utf-8"?>
+<p:sld xmlns:a="http://schemas.openxmlformats.org/drawingml/2006/main" xmlns:r="http://schemas.openxmlformats.org/officeDocument/2006/relationships" xmlns:p="http://schemas.openxmlformats.org/presentationml/2006/main">
+  <p:cSld name="Slide 11">
+    <p:spTree>
+      <p:nvGrpSpPr>
+        <p:cNvPr id="1" name=""/>
+        <p:cNvGrpSpPr/>
+        <p:nvPr/>
+      </p:nvGrpSpPr>
+      <p:grpSpPr>
+        <a:xfrm>
+          <a:off x="0" y="0"/>
+          <a:ext cx="0" cy="0"/>
+          <a:chOff x="0" y="0"/>
+          <a:chExt cx="0" cy="0"/>
+        </a:xfrm>
+      </p:grpSpPr>
+      <p:sp>
+        <p:nvSpPr>
+          <p:cNvPr id="2" name="Text 0"/>
+          <p:cNvSpPr/>
+          <p:nvPr>
+            <p:ph idx="100" type="title" hasCustomPrompt="1"/>
+          </p:nvPr>
+        </p:nvSpPr>
+        <p:spPr>
+          <a:xfrm>
+            <a:off x="457200" y="256032"/>
+            <a:ext cx="8229600" cy="640080"/>
+          </a:xfrm>
+          <a:prstGeom prst="rect">
+            <a:avLst/>
+          </a:prstGeom>
+          <a:noFill/>
+          <a:ln/>
+        </p:spPr>
+        <p:txBody>
+          <a:bodyPr wrap="square" lIns="0" tIns="0" rIns="0" bIns="0" rtlCol="0" anchor="ctr"/>
+          <a:lstStyle/>
+          <a:p>
+            <a:pPr algn="l" indent="0" marL="0">
+              <a:buNone/>
+            </a:pPr>
+            <a:r>
+              <a:rPr lang="en-US" sz="3000" b="1" dirty="0">
+                <a:solidFill>
+                  <a:schemeClr val="tx1"/>
+                </a:solidFill>
+              </a:rPr>
+              <a:t>Audit Log, Settings, languages</a:t>
+            </a:r>
+            <a:endParaRPr lang="en-US" sz="3000" dirty="0"/>
+          </a:p>
+        </p:txBody>
+      </p:sp>
+      <p:sp>
+        <p:nvSpPr>
+          <p:cNvPr id="3" name="Audit Log screenshot frame"/>
+          <p:cNvSpPr/>
+          <p:nvPr/>
+        </p:nvSpPr>
+        <p:spPr>
+          <a:xfrm>
+            <a:off x="457200" y="1051560"/>
+            <a:ext cx="5120640" cy="2926080"/>
+          </a:xfrm>
+          <a:prstGeom prst="rect">
+            <a:avLst/>
+          </a:prstGeom>
+          <a:solidFill>
+            <a:schemeClr val="bg1"/>
+          </a:solidFill>
+          <a:ln w="12700">
+            <a:solidFill>
+              <a:schemeClr val="bg2"/>
+            </a:solidFill>
+            <a:prstDash val="solid"/>
+          </a:ln>
+          <a:effectLst>
+            <a:outerShdw sx="100000" sy="100000" kx="0" ky="0" algn="bl" rotWithShape="0" blurRad="101600" dist="25400" dir="5400000">
+              <a:srgbClr val="000000">
+                <a:alpha val="22000"/>
+              </a:srgbClr>
+            </a:outerShdw>
+          </a:effectLst>
+        </p:spPr>
+      </p:sp>
+      <p:pic>
+        <p:nvPicPr>
+          <p:cNvPr id="4" name="Audit Log screenshot" descr="Audit Log screenshot">    </p:cNvPr>
+          <p:cNvPicPr>
+            <a:picLocks noChangeAspect="1"/>
+          </p:cNvPicPr>
+          <p:nvPr/>
+        </p:nvPicPr>
+        <p:blipFill>
+          <a:blip r:embed="rId1"/>
+          <a:stretch>
+            <a:fillRect/>
+          </a:stretch>
+        </p:blipFill>
+        <p:spPr>
+          <a:xfrm>
+            <a:off x="484632" y="1078992"/>
+            <a:ext cx="5065776" cy="2871216"/>
+          </a:xfrm>
+          <a:prstGeom prst="rect">
+            <a:avLst/>
+          </a:prstGeom>
+        </p:spPr>
+      </p:pic>
+      <p:sp>
+        <p:nvSpPr>
+          <p:cNvPr id="5" name="Text 2"/>
+          <p:cNvSpPr txBox="1"/>
+          <p:nvPr/>
+        </p:nvSpPr>
+        <p:spPr>
+          <a:xfrm>
+            <a:off x="457200" y="4041648"/>
+            <a:ext cx="5120640" cy="274320"/>
+          </a:xfrm>
+          <a:prstGeom prst="rect">
+            <a:avLst/>
+          </a:prstGeom>
+          <a:noFill/>
+          <a:ln/>
+        </p:spPr>
+        <p:txBody>
+          <a:bodyPr wrap="square" lIns="0" tIns="0" rIns="0" bIns="0" rtlCol="0" anchor="ctr"/>
+          <a:lstStyle/>
+          <a:p>
+            <a:pPr algn="l" indent="0" marL="0">
+              <a:buNone/>
+            </a:pPr>
+            <a:r>
+              <a:rPr lang="en-US" sz="1100" i="1" dirty="0">
+                <a:solidFill>
+                  <a:schemeClr val="tx2"/>
+                </a:solidFill>
+              </a:rPr>
+              <a:t>Audit Log: who changed what and when (FR-012)</a:t>
+            </a:r>
+            <a:endParaRPr lang="en-US" sz="1100" dirty="0"/>
+          </a:p>
+        </p:txBody>
+      </p:sp>
+      <p:sp>
+        <p:nvSpPr>
+          <p:cNvPr id="6" name="Settings screenshot frame"/>
+          <p:cNvSpPr/>
+          <p:nvPr/>
+        </p:nvSpPr>
+        <p:spPr>
+          <a:xfrm>
+            <a:off x="5852160" y="1051560"/>
+            <a:ext cx="2834640" cy="1417320"/>
+          </a:xfrm>
+          <a:prstGeom prst="rect">
+            <a:avLst/>
+          </a:prstGeom>
+          <a:solidFill>
+            <a:schemeClr val="bg1"/>
+          </a:solidFill>
+          <a:ln w="12700">
+            <a:solidFill>
+              <a:schemeClr val="bg2"/>
+            </a:solidFill>
+            <a:prstDash val="solid"/>
+          </a:ln>
+          <a:effectLst>
+            <a:outerShdw sx="100000" sy="100000" kx="0" ky="0" algn="bl" rotWithShape="0" blurRad="101600" dist="25400" dir="5400000">
+              <a:srgbClr val="000000">
+                <a:alpha val="22000"/>
+              </a:srgbClr>
+            </a:outerShdw>
+          </a:effectLst>
+        </p:spPr>
+      </p:sp>
+      <p:pic>
+        <p:nvPicPr>
+          <p:cNvPr id="7" name="Settings screenshot" descr="Settings screenshot">    </p:cNvPr>
+          <p:cNvPicPr>
+            <a:picLocks noChangeAspect="1"/>
+          </p:cNvPicPr>
+          <p:nvPr/>
+        </p:nvPicPr>
+        <p:blipFill>
+          <a:blip r:embed="rId2"/>
+          <a:stretch>
+            <a:fillRect/>
+          </a:stretch>
+        </p:blipFill>
+        <p:spPr>
+          <a:xfrm>
+            <a:off x="5879592" y="1078992"/>
+            <a:ext cx="2779776" cy="1362456"/>
+          </a:xfrm>
+          <a:prstGeom prst="rect">
+            <a:avLst/>
+          </a:prstGeom>
+        </p:spPr>
+      </p:pic>
+      <p:sp>
+        <p:nvSpPr>
+          <p:cNvPr id="8" name="Text 4"/>
+          <p:cNvSpPr txBox="1"/>
+          <p:nvPr/>
+        </p:nvSpPr>
+        <p:spPr>
+          <a:xfrm>
+            <a:off x="5852160" y="2514600"/>
+            <a:ext cx="2834640" cy="274320"/>
+          </a:xfrm>
+          <a:prstGeom prst="rect">
+            <a:avLst/>
+          </a:prstGeom>
+          <a:noFill/>
+          <a:ln/>
+        </p:spPr>
+        <p:txBody>
+          <a:bodyPr wrap="square" lIns="0" tIns="0" rIns="0" bIns="0" rtlCol="0" anchor="ctr"/>
+          <a:lstStyle/>
+          <a:p>
+            <a:pPr algn="l" indent="0" marL="0">
+              <a:buNone/>
+            </a:pPr>
+            <a:r>
+              <a:rPr lang="en-US" sz="1100" i="1" dirty="0">
+                <a:solidFill>
+                  <a:schemeClr val="tx2"/>
+                </a:solidFill>
+              </a:rPr>
+              <a:t>Settings: alert thresholds, tax %, payment days</a:t>
+            </a:r>
+            <a:endParaRPr lang="en-US" sz="1100" dirty="0"/>
+          </a:p>
+        </p:txBody>
+      </p:sp>
+      <p:sp>
+        <p:nvSpPr>
+          <p:cNvPr id="9" name="Clients app in German frame"/>
+          <p:cNvSpPr/>
+          <p:nvPr/>
+        </p:nvSpPr>
+        <p:spPr>
+          <a:xfrm>
+            <a:off x="5852160" y="2880360"/>
+            <a:ext cx="2834640" cy="1417320"/>
+          </a:xfrm>
+          <a:prstGeom prst="rect">
+            <a:avLst/>
+          </a:prstGeom>
+          <a:solidFill>
+            <a:schemeClr val="bg1"/>
+          </a:solidFill>
+          <a:ln w="12700">
+            <a:solidFill>
+              <a:schemeClr val="bg2"/>
+            </a:solidFill>
+            <a:prstDash val="solid"/>
+          </a:ln>
+          <a:effectLst>
+            <a:outerShdw sx="100000" sy="100000" kx="0" ky="0" algn="bl" rotWithShape="0" blurRad="101600" dist="25400" dir="5400000">
+              <a:srgbClr val="000000">
+                <a:alpha val="22000"/>
+              </a:srgbClr>
+            </a:outerShdw>
+          </a:effectLst>
+        </p:spPr>
+      </p:sp>
+      <p:pic>
+        <p:nvPicPr>
+          <p:cNvPr id="10" name="Clients app in German" descr="Clients app in German">    </p:cNvPr>
+          <p:cNvPicPr>
+            <a:picLocks noChangeAspect="1"/>
+          </p:cNvPicPr>
+          <p:nvPr/>
+        </p:nvPicPr>
+        <p:blipFill>
+          <a:blip r:embed="rId3"/>
+          <a:stretch>
+            <a:fillRect/>
+          </a:stretch>
+        </p:blipFill>
+        <p:spPr>
+          <a:xfrm>
+            <a:off x="5879592" y="2907792"/>
+            <a:ext cx="2779776" cy="1362456"/>
+          </a:xfrm>
+          <a:prstGeom prst="rect">
+            <a:avLst/>
+          </a:prstGeom>
+        </p:spPr>
+      </p:pic>
+      <p:sp>
+        <p:nvSpPr>
+          <p:cNvPr id="11" name="Text 6"/>
+          <p:cNvSpPr txBox="1"/>
+          <p:nvPr/>
+        </p:nvSpPr>
+        <p:spPr>
+          <a:xfrm>
+            <a:off x="5852160" y="4343400"/>
+            <a:ext cx="2834640" cy="274320"/>
+          </a:xfrm>
+          <a:prstGeom prst="rect">
+            <a:avLst/>
+          </a:prstGeom>
+          <a:noFill/>
+          <a:ln/>
+        </p:spPr>
+        <p:txBody>
+          <a:bodyPr wrap="square" lIns="0" tIns="0" rIns="0" bIns="0" rtlCol="0" anchor="ctr"/>
+          <a:lstStyle/>
+          <a:p>
+            <a:pPr algn="l" indent="0" marL="0">
+              <a:buNone/>
+            </a:pPr>
+            <a:r>
+              <a:rPr lang="en-US" sz="1100" i="1" dirty="0">
+                <a:solidFill>
+                  <a:schemeClr val="tx2"/>
+                </a:solidFill>
+              </a:rPr>
+              <a:t>Labels in English, German, Hindi</a:t>
+            </a:r>
+            <a:endParaRPr lang="en-US" sz="1100" dirty="0"/>
+          </a:p>
+        </p:txBody>
+      </p:sp>
+      <p:sp>
+        <p:nvSpPr>
+          <p:cNvPr id="25" name="Slide Number Placeholder 0"/>
+          <p:cNvSpPr>
+            <a:spLocks noGrp="1"/>
+          </p:cNvSpPr>
+          <p:nvPr>
+            <p:ph type="sldNum" sz="quarter" idx="4294967295"/>
+          </p:nvPr>
+        </p:nvSpPr>
+        <p:spPr>
+          <a:xfrm>
+            <a:off x="8229600" y="4800600"/>
+            <a:ext cx="457200" cy="228600"/>
+          </a:xfrm>
+          <a:prstGeom prst="rect">
+            <a:avLst/>
+          </a:prstGeom>
+          <a:extLst>
+            <a:ext uri="{C572A759-6A51-4108-AA02-DFA0A04FC94B}">
+              <ma14:wrappingTextBoxFlag xmlns:ma14="http://schemas.microsoft.com/office/mac/drawingml/2011/main" val="0"/>
+            </a:ext>
+          </a:extLst>
+        </p:spPr>
+        <p:txBody>
+          <a:bodyPr/>
+          <a:lstStyle>
+            <a:lvl1pPr>
+              <a:defRPr sz="900">
+                <a:solidFill>
+                  <a:schemeClr val="tx2"/>
+                </a:solidFill>
+              </a:defRPr>
+            </a:lvl1pPr>
+          </a:lstStyle>
+          <a:p>
+            <a:pPr algn="r"/>
+            <a:fld id="{F7021451-1387-4CA6-816F-3879F97B5CBC}" type="slidenum">
+              <a:rPr b="0" lang="en-US"/>
+              <a:t>11</a:t>
+            </a:fld>
+            <a:endParaRPr lang="en-US"/>
+          </a:p>
+        </p:txBody>
+      </p:sp>
+    </p:spTree>
+  </p:cSld>
+  <p:clrMapOvr>
+    <a:masterClrMapping/>
+  </p:clrMapOvr>
+</p:sld>
+</file>
+
+<file path=ppt/slides/slide12.xml><?xml version="1.0" encoding="utf-8"?>
+<p:sld xmlns:a="http://schemas.openxmlformats.org/drawingml/2006/main" xmlns:r="http://schemas.openxmlformats.org/officeDocument/2006/relationships" xmlns:p="http://schemas.openxmlformats.org/presentationml/2006/main">
+  <p:cSld name="Slide 12">
+    <p:spTree>
+      <p:nvGrpSpPr>
+        <p:cNvPr id="1" name=""/>
+        <p:cNvGrpSpPr/>
+        <p:nvPr/>
+      </p:nvGrpSpPr>
+      <p:grpSpPr>
+        <a:xfrm>
+          <a:off x="0" y="0"/>
+          <a:ext cx="0" cy="0"/>
+          <a:chOff x="0" y="0"/>
+          <a:chExt cx="0" cy="0"/>
+        </a:xfrm>
+      </p:grpSpPr>
+      <p:sp>
+        <p:nvSpPr>
+          <p:cNvPr id="2" name="Text 0"/>
+          <p:cNvSpPr/>
+          <p:nvPr>
+            <p:ph idx="100" type="title" hasCustomPrompt="1"/>
+          </p:nvPr>
+        </p:nvSpPr>
+        <p:spPr>
+          <a:xfrm>
+            <a:off x="457200" y="256032"/>
+            <a:ext cx="8229600" cy="640080"/>
+          </a:xfrm>
+          <a:prstGeom prst="rect">
+            <a:avLst/>
+          </a:prstGeom>
+          <a:noFill/>
+          <a:ln/>
+        </p:spPr>
+        <p:txBody>
+          <a:bodyPr wrap="square" lIns="0" tIns="0" rIns="0" bIns="0" rtlCol="0" anchor="ctr"/>
+          <a:lstStyle/>
+          <a:p>
+            <a:pPr algn="l" indent="0" marL="0">
+              <a:buNone/>
+            </a:pPr>
+            <a:r>
+              <a:rPr lang="en-US" sz="3000" b="1" dirty="0">
+                <a:solidFill>
+                  <a:schemeClr val="bg1"/>
+                </a:solidFill>
+              </a:rPr>
+              <a:t>Delivery and CI/CD</a:t>
+            </a:r>
+            <a:endParaRPr lang="en-US" sz="3000" dirty="0"/>
+          </a:p>
+        </p:txBody>
+      </p:sp>
+      <p:sp>
+        <p:nvSpPr>
+          <p:cNvPr id="3" name="Push / merge icon circle"/>
+          <p:cNvSpPr/>
+          <p:nvPr/>
+        </p:nvSpPr>
+        <p:spPr>
+          <a:xfrm>
+            <a:off x="822960" y="1143000"/>
+            <a:ext cx="731520" cy="731520"/>
+          </a:xfrm>
+          <a:prstGeom prst="ellipse">
+            <a:avLst/>
+          </a:prstGeom>
+          <a:solidFill>
+            <a:schemeClr val="accent1"/>
+          </a:solidFill>
+          <a:ln/>
+        </p:spPr>
+      </p:sp>
+      <p:pic>
+        <p:nvPicPr>
+          <p:cNvPr id="4" name="Push / merge icon" descr="Push / merge icon">    </p:cNvPr>
+          <p:cNvPicPr>
+            <a:picLocks noChangeAspect="1"/>
+          </p:cNvPicPr>
+          <p:nvPr/>
+        </p:nvPicPr>
+        <p:blipFill>
+          <a:blip r:embed="rId1"/>
+          <a:stretch>
+            <a:fillRect/>
+          </a:stretch>
+        </p:blipFill>
+        <p:spPr>
+          <a:xfrm>
             <a:off x="998525" y="1318565"/>
             <a:ext cx="380390" cy="380390"/>
           </a:xfrm>
@@ -3720,7 +4607,7 @@
             <a:pPr algn="r"/>
             <a:fld id="{F7021451-1387-4CA6-816F-3879F97B5CBC}" type="slidenum">
               <a:rPr b="0" lang="en-US"/>
-              <a:t>10</a:t>
+              <a:t>12</a:t>
             </a:fld>
             <a:endParaRPr lang="en-US"/>
           </a:p>
@@ -6818,7 +7705,7 @@
                   <a:schemeClr val="tx1"/>
                 </a:solidFill>
               </a:rPr>
-              <a:t>Roles, security and launchpad</a:t>
+              <a:t>Launchpad and roles</a:t>
             </a:r>
             <a:endParaRPr lang="en-US" sz="3000" dirty="0"/>
           </a:p>
@@ -6826,14 +7713,14 @@
       </p:sp>
       <p:sp>
         <p:nvSpPr>
-          <p:cNvPr id="3" name="Admin launchpad tiles frame"/>
+          <p:cNvPr id="3" name="Admin launchpad frame"/>
           <p:cNvSpPr/>
           <p:nvPr/>
         </p:nvSpPr>
         <p:spPr>
           <a:xfrm>
-            <a:off x="457200" y="1143000"/>
-            <a:ext cx="5120640" cy="1773936"/>
+            <a:off x="457200" y="1051560"/>
+            <a:ext cx="6309360" cy="2185416"/>
           </a:xfrm>
           <a:prstGeom prst="rect">
             <a:avLst/>
@@ -6858,7 +7745,7 @@
       </p:sp>
       <p:pic>
         <p:nvPicPr>
-          <p:cNvPr id="4" name="Admin launchpad tiles" descr="Admin launchpad tiles">    </p:cNvPr>
+          <p:cNvPr id="4" name="Admin launchpad" descr="Admin launchpad">    </p:cNvPr>
           <p:cNvPicPr>
             <a:picLocks noChangeAspect="1"/>
           </p:cNvPicPr>
@@ -6872,8 +7759,8 @@
         </p:blipFill>
         <p:spPr>
           <a:xfrm>
-            <a:off x="484632" y="1170432"/>
-            <a:ext cx="5065776" cy="1719072"/>
+            <a:off x="484632" y="1078992"/>
+            <a:ext cx="6254496" cy="2130552"/>
           </a:xfrm>
           <a:prstGeom prst="rect">
             <a:avLst/>
@@ -6888,8 +7775,8 @@
         </p:nvSpPr>
         <p:spPr>
           <a:xfrm>
-            <a:off x="457200" y="2999232"/>
-            <a:ext cx="5120640" cy="274320"/>
+            <a:off x="457200" y="3310128"/>
+            <a:ext cx="6309360" cy="274320"/>
           </a:xfrm>
           <a:prstGeom prst="rect">
             <a:avLst/>
@@ -6910,7 +7797,7 @@
                   <a:schemeClr val="tx2"/>
                 </a:solidFill>
               </a:rPr>
-              <a:t>Admin: 9 apps, starts on Manager Home</a:t>
+              <a:t>Admin (PSA_Admin): 9 apps, starts on Manager Home</a:t>
             </a:r>
             <a:endParaRPr lang="en-US" sz="1100" dirty="0"/>
           </a:p>
@@ -6918,14 +7805,14 @@
       </p:sp>
       <p:sp>
         <p:nvSpPr>
-          <p:cNvPr id="6" name="User launchpad tile frame"/>
+          <p:cNvPr id="6" name="User launchpad frame"/>
           <p:cNvSpPr/>
           <p:nvPr/>
         </p:nvSpPr>
         <p:spPr>
           <a:xfrm>
-            <a:off x="457200" y="3383280"/>
-            <a:ext cx="1783080" cy="1078992"/>
+            <a:off x="6995160" y="1051560"/>
+            <a:ext cx="1691640" cy="996696"/>
           </a:xfrm>
           <a:prstGeom prst="rect">
             <a:avLst/>
@@ -6950,7 +7837,7 @@
       </p:sp>
       <p:pic>
         <p:nvPicPr>
-          <p:cNvPr id="7" name="User launchpad tile" descr="User launchpad tile">    </p:cNvPr>
+          <p:cNvPr id="7" name="User launchpad" descr="User launchpad">    </p:cNvPr>
           <p:cNvPicPr>
             <a:picLocks noChangeAspect="1"/>
           </p:cNvPicPr>
@@ -6964,8 +7851,8 @@
         </p:blipFill>
         <p:spPr>
           <a:xfrm>
-            <a:off x="484632" y="3410712"/>
-            <a:ext cx="1728216" cy="1024128"/>
+            <a:off x="7022592" y="1078992"/>
+            <a:ext cx="1636776" cy="941832"/>
           </a:xfrm>
           <a:prstGeom prst="rect">
             <a:avLst/>
@@ -6980,45 +7867,31 @@
         </p:nvSpPr>
         <p:spPr>
           <a:xfrm>
-            <a:off x="2423160" y="3611880"/>
-            <a:ext cx="3108960" cy="640080"/>
-          </a:xfrm>
-          <a:prstGeom prst="rect">
-            <a:avLst/>
-          </a:prstGeom>
-          <a:noFill/>
-          <a:ln/>
-        </p:spPr>
-        <p:txBody>
-          <a:bodyPr wrap="square" lIns="0" tIns="0" rIns="0" bIns="0" rtlCol="0" anchor="t"/>
-          <a:lstStyle/>
-          <a:p>
-            <a:pPr indent="0" marL="0">
-              <a:buNone/>
-            </a:pPr>
-            <a:r>
-              <a:rPr lang="en-US" sz="1200" b="1" dirty="0">
-                <a:solidFill>
-                  <a:schemeClr val="tx1"/>
+            <a:off x="6995160" y="2103120"/>
+            <a:ext cx="1691640" cy="274320"/>
+          </a:xfrm>
+          <a:prstGeom prst="rect">
+            <a:avLst/>
+          </a:prstGeom>
+          <a:noFill/>
+          <a:ln/>
+        </p:spPr>
+        <p:txBody>
+          <a:bodyPr wrap="square" lIns="0" tIns="0" rIns="0" bIns="0" rtlCol="0" anchor="ctr"/>
+          <a:lstStyle/>
+          <a:p>
+            <a:pPr algn="l" indent="0" marL="0">
+              <a:buNone/>
+            </a:pPr>
+            <a:r>
+              <a:rPr lang="en-US" sz="1100" i="1" dirty="0">
+                <a:solidFill>
+                  <a:schemeClr val="tx2"/>
                 </a:solidFill>
               </a:rPr>
               <a:t>User: only My Timesheets</a:t>
             </a:r>
-            <a:endParaRPr lang="en-US" sz="1200" dirty="0"/>
-          </a:p>
-          <a:p>
-            <a:pPr indent="0" marL="0">
-              <a:buNone/>
-            </a:pPr>
-            <a:r>
-              <a:rPr lang="en-US" sz="1200" dirty="0">
-                <a:solidFill>
-                  <a:schemeClr val="tx1"/>
-                </a:solidFill>
-              </a:rPr>
-              <a:t>server returns no other data</a:t>
-            </a:r>
-            <a:endParaRPr lang="en-US" sz="1200" dirty="0"/>
+            <a:endParaRPr lang="en-US" sz="1100" dirty="0"/>
           </a:p>
         </p:txBody>
       </p:sp>
@@ -7030,8 +7903,8 @@
         </p:nvSpPr>
         <p:spPr>
           <a:xfrm>
-            <a:off x="5897880" y="1143000"/>
-            <a:ext cx="2834640" cy="1463040"/>
+            <a:off x="457200" y="3703320"/>
+            <a:ext cx="8229600" cy="1005840"/>
           </a:xfrm>
           <a:prstGeom prst="rect">
             <a:avLst/>
@@ -7056,7 +7929,7 @@
                   <a:schemeClr val="tx1"/>
                 </a:solidFill>
               </a:rPr>
-              <a:t>XSUAA role collections PSA_Admin / PSA_User</a:t>
+              <a:t>XSUAA roles Admin / User</a:t>
             </a:r>
             <a:endParaRPr lang="en-US" sz="1200" dirty="0"/>
           </a:p>
@@ -7074,7 +7947,7 @@
                   <a:schemeClr val="tx1"/>
                 </a:solidFill>
               </a:rPr>
-              <a:t>Row-level: own timesheets only ($user)</a:t>
+              <a:t>Row-level security: own timesheets only ($user)</a:t>
             </a:r>
             <a:endParaRPr lang="en-US" sz="1200" dirty="0"/>
           </a:p>
@@ -7096,97 +7969,23 @@
             </a:r>
             <a:endParaRPr lang="en-US" sz="1200" dirty="0"/>
           </a:p>
-        </p:txBody>
-      </p:sp>
-      <p:sp>
-        <p:nvSpPr>
-          <p:cNvPr id="10" name="Clients app in German frame"/>
-          <p:cNvSpPr/>
-          <p:nvPr/>
-        </p:nvSpPr>
-        <p:spPr>
-          <a:xfrm>
-            <a:off x="5897880" y="2697480"/>
-            <a:ext cx="2788920" cy="1673352"/>
-          </a:xfrm>
-          <a:prstGeom prst="rect">
-            <a:avLst/>
-          </a:prstGeom>
-          <a:solidFill>
-            <a:schemeClr val="bg1"/>
-          </a:solidFill>
-          <a:ln w="12700">
-            <a:solidFill>
-              <a:schemeClr val="bg2"/>
-            </a:solidFill>
-            <a:prstDash val="solid"/>
-          </a:ln>
-          <a:effectLst>
-            <a:outerShdw sx="100000" sy="100000" kx="0" ky="0" algn="bl" rotWithShape="0" blurRad="101600" dist="25400" dir="5400000">
-              <a:srgbClr val="000000">
-                <a:alpha val="22000"/>
-              </a:srgbClr>
-            </a:outerShdw>
-          </a:effectLst>
-        </p:spPr>
-      </p:sp>
-      <p:pic>
-        <p:nvPicPr>
-          <p:cNvPr id="11" name="Clients app in German" descr="Clients app in German">    </p:cNvPr>
-          <p:cNvPicPr>
-            <a:picLocks noChangeAspect="1"/>
-          </p:cNvPicPr>
-          <p:nvPr/>
-        </p:nvPicPr>
-        <p:blipFill>
-          <a:blip r:embed="rId3"/>
-          <a:stretch>
-            <a:fillRect/>
-          </a:stretch>
-        </p:blipFill>
-        <p:spPr>
-          <a:xfrm>
-            <a:off x="5925312" y="2724912"/>
-            <a:ext cx="2734056" cy="1618488"/>
-          </a:xfrm>
-          <a:prstGeom prst="rect">
-            <a:avLst/>
-          </a:prstGeom>
-        </p:spPr>
-      </p:pic>
-      <p:sp>
-        <p:nvSpPr>
-          <p:cNvPr id="12" name="Text 7"/>
-          <p:cNvSpPr txBox="1"/>
-          <p:nvPr/>
-        </p:nvSpPr>
-        <p:spPr>
-          <a:xfrm>
-            <a:off x="5897880" y="4434840"/>
-            <a:ext cx="2788920" cy="274320"/>
-          </a:xfrm>
-          <a:prstGeom prst="rect">
-            <a:avLst/>
-          </a:prstGeom>
-          <a:noFill/>
-          <a:ln/>
-        </p:spPr>
-        <p:txBody>
-          <a:bodyPr wrap="square" lIns="0" tIns="0" rIns="0" bIns="0" rtlCol="0" anchor="ctr"/>
-          <a:lstStyle/>
-          <a:p>
-            <a:pPr algn="l" indent="0" marL="0">
-              <a:buNone/>
-            </a:pPr>
-            <a:r>
-              <a:rPr lang="en-US" sz="1100" i="1" dirty="0">
-                <a:solidFill>
-                  <a:schemeClr val="tx2"/>
-                </a:solidFill>
-              </a:rPr>
-              <a:t>Labels from db/i18n: EN · DE · HI</a:t>
-            </a:r>
-            <a:endParaRPr lang="en-US" sz="1100" dirty="0"/>
+          <a:p>
+            <a:pPr marL="177800" indent="-177800">
+              <a:spcAft>
+                <a:spcPts val="800"/>
+              </a:spcAft>
+              <a:buSzPct val="100000"/>
+              <a:buChar char="•"/>
+            </a:pPr>
+            <a:r>
+              <a:rPr lang="en-US" sz="1200" dirty="0">
+                <a:solidFill>
+                  <a:schemeClr val="tx1"/>
+                </a:solidFill>
+              </a:rPr>
+              <a:t>Start page per role (whoAmI)</a:t>
+            </a:r>
+            <a:endParaRPr lang="en-US" sz="1200" dirty="0"/>
           </a:p>
         </p:txBody>
       </p:sp>
@@ -7292,7 +8091,7 @@
                   <a:schemeClr val="tx1"/>
                 </a:solidFill>
               </a:rPr>
-              <a:t>Manager Home – Analytical List Page</a:t>
+              <a:t>Manager Home (Analytical List Page)</a:t>
             </a:r>
             <a:endParaRPr lang="en-US" sz="3000" dirty="0"/>
           </a:p>
@@ -7306,8 +8105,8 @@
         </p:nvSpPr>
         <p:spPr>
           <a:xfrm>
-            <a:off x="457200" y="1097280"/>
-            <a:ext cx="5577840" cy="3346704"/>
+            <a:off x="457200" y="1051560"/>
+            <a:ext cx="6309360" cy="3611880"/>
           </a:xfrm>
           <a:prstGeom prst="rect">
             <a:avLst/>
@@ -7346,8 +8145,8 @@
         </p:blipFill>
         <p:spPr>
           <a:xfrm>
-            <a:off x="484632" y="1124712"/>
-            <a:ext cx="5522976" cy="3291840"/>
+            <a:off x="484632" y="1078992"/>
+            <a:ext cx="6254496" cy="3557016"/>
           </a:xfrm>
           <a:prstGeom prst="rect">
             <a:avLst/>
@@ -7356,24 +8155,31 @@
       </p:pic>
       <p:sp>
         <p:nvSpPr>
-          <p:cNvPr id="5" name="pill KPI · Active Projects"/>
+          <p:cNvPr id="5" name="highlight KPI tags"/>
           <p:cNvSpPr/>
           <p:nvPr/>
         </p:nvSpPr>
         <p:spPr>
           <a:xfrm>
-            <a:off x="6355080" y="1143000"/>
-            <a:ext cx="2331720" cy="329184"/>
+            <a:off x="1411248" y="1315873"/>
+            <a:ext cx="969630" cy="218167"/>
           </a:xfrm>
           <a:prstGeom prst="roundRect">
             <a:avLst>
-              <a:gd name="adj" fmla="val 50000"/>
+              <a:gd name="adj" fmla="val 25148"/>
             </a:avLst>
           </a:prstGeom>
           <a:solidFill>
-            <a:schemeClr val="accent1"/>
+            <a:schemeClr val="bg1">
+              <a:alpha val="0"/>
+            </a:schemeClr>
           </a:solidFill>
-          <a:ln/>
+          <a:ln w="31750">
+            <a:solidFill>
+              <a:schemeClr val="accent2"/>
+            </a:solidFill>
+            <a:prstDash val="solid"/>
+          </a:ln>
         </p:spPr>
       </p:sp>
       <p:sp>
@@ -7384,160 +8190,44 @@
         </p:nvSpPr>
         <p:spPr>
           <a:xfrm>
-            <a:off x="6355080" y="1143000"/>
-            <a:ext cx="2331720" cy="329184"/>
-          </a:xfrm>
-          <a:prstGeom prst="rect">
-            <a:avLst/>
-          </a:prstGeom>
-          <a:noFill/>
-          <a:ln/>
-        </p:spPr>
-        <p:txBody>
-          <a:bodyPr wrap="square" lIns="0" tIns="0" rIns="0" bIns="0" rtlCol="0" anchor="ctr"/>
-          <a:lstStyle/>
-          <a:p>
-            <a:pPr algn="ctr" indent="0" marL="0">
-              <a:buNone/>
-            </a:pPr>
-            <a:r>
-              <a:rPr lang="en-US" sz="1100" b="1" dirty="0">
-                <a:solidFill>
-                  <a:schemeClr val="bg1"/>
-                </a:solidFill>
-              </a:rPr>
-              <a:t>KPI · Active Projects</a:t>
-            </a:r>
-            <a:endParaRPr lang="en-US" sz="1100" dirty="0"/>
-          </a:p>
-        </p:txBody>
-      </p:sp>
-      <p:sp>
-        <p:nvSpPr>
-          <p:cNvPr id="7" name="pill KPI · At-Risk Budgets"/>
-          <p:cNvSpPr/>
-          <p:nvPr/>
-        </p:nvSpPr>
-        <p:spPr>
-          <a:xfrm>
-            <a:off x="6355080" y="1600200"/>
-            <a:ext cx="2331720" cy="329184"/>
-          </a:xfrm>
-          <a:prstGeom prst="roundRect">
-            <a:avLst>
-              <a:gd name="adj" fmla="val 50000"/>
-            </a:avLst>
-          </a:prstGeom>
-          <a:solidFill>
-            <a:schemeClr val="accent3"/>
-          </a:solidFill>
-          <a:ln/>
-        </p:spPr>
-      </p:sp>
-      <p:sp>
-        <p:nvSpPr>
-          <p:cNvPr id="8" name="Text 5"/>
+            <a:off x="6995160" y="1051560"/>
+            <a:ext cx="1691640" cy="548640"/>
+          </a:xfrm>
+          <a:prstGeom prst="rect">
+            <a:avLst/>
+          </a:prstGeom>
+          <a:noFill/>
+          <a:ln/>
+        </p:spPr>
+        <p:txBody>
+          <a:bodyPr wrap="square" lIns="0" tIns="0" rIns="0" bIns="0" rtlCol="0" anchor="t"/>
+          <a:lstStyle/>
+          <a:p>
+            <a:pPr indent="0" marL="0">
+              <a:buNone/>
+            </a:pPr>
+            <a:r>
+              <a:rPr lang="en-US" sz="1400" b="1" dirty="0">
+                <a:solidFill>
+                  <a:schemeClr val="accent1"/>
+                </a:solidFill>
+              </a:rPr>
+              <a:t>KPIs + chart + table</a:t>
+            </a:r>
+            <a:endParaRPr lang="en-US" sz="1400" dirty="0"/>
+          </a:p>
+        </p:txBody>
+      </p:sp>
+      <p:sp>
+        <p:nvSpPr>
+          <p:cNvPr id="7" name="Text 4"/>
           <p:cNvSpPr txBox="1"/>
           <p:nvPr/>
         </p:nvSpPr>
         <p:spPr>
           <a:xfrm>
-            <a:off x="6355080" y="1600200"/>
-            <a:ext cx="2331720" cy="329184"/>
-          </a:xfrm>
-          <a:prstGeom prst="rect">
-            <a:avLst/>
-          </a:prstGeom>
-          <a:noFill/>
-          <a:ln/>
-        </p:spPr>
-        <p:txBody>
-          <a:bodyPr wrap="square" lIns="0" tIns="0" rIns="0" bIns="0" rtlCol="0" anchor="ctr"/>
-          <a:lstStyle/>
-          <a:p>
-            <a:pPr algn="ctr" indent="0" marL="0">
-              <a:buNone/>
-            </a:pPr>
-            <a:r>
-              <a:rPr lang="en-US" sz="1100" b="1" dirty="0">
-                <a:solidFill>
-                  <a:schemeClr val="bg1"/>
-                </a:solidFill>
-              </a:rPr>
-              <a:t>KPI · At-Risk Budgets</a:t>
-            </a:r>
-            <a:endParaRPr lang="en-US" sz="1100" dirty="0"/>
-          </a:p>
-        </p:txBody>
-      </p:sp>
-      <p:sp>
-        <p:nvSpPr>
-          <p:cNvPr id="9" name="pill KPI · Pending Approvals"/>
-          <p:cNvSpPr/>
-          <p:nvPr/>
-        </p:nvSpPr>
-        <p:spPr>
-          <a:xfrm>
-            <a:off x="6355080" y="2057400"/>
-            <a:ext cx="2331720" cy="329184"/>
-          </a:xfrm>
-          <a:prstGeom prst="roundRect">
-            <a:avLst>
-              <a:gd name="adj" fmla="val 50000"/>
-            </a:avLst>
-          </a:prstGeom>
-          <a:solidFill>
-            <a:schemeClr val="accent2"/>
-          </a:solidFill>
-          <a:ln/>
-        </p:spPr>
-      </p:sp>
-      <p:sp>
-        <p:nvSpPr>
-          <p:cNvPr id="10" name="Text 7"/>
-          <p:cNvSpPr txBox="1"/>
-          <p:nvPr/>
-        </p:nvSpPr>
-        <p:spPr>
-          <a:xfrm>
-            <a:off x="6355080" y="2057400"/>
-            <a:ext cx="2331720" cy="329184"/>
-          </a:xfrm>
-          <a:prstGeom prst="rect">
-            <a:avLst/>
-          </a:prstGeom>
-          <a:noFill/>
-          <a:ln/>
-        </p:spPr>
-        <p:txBody>
-          <a:bodyPr wrap="square" lIns="0" tIns="0" rIns="0" bIns="0" rtlCol="0" anchor="ctr"/>
-          <a:lstStyle/>
-          <a:p>
-            <a:pPr algn="ctr" indent="0" marL="0">
-              <a:buNone/>
-            </a:pPr>
-            <a:r>
-              <a:rPr lang="en-US" sz="1100" b="1" dirty="0">
-                <a:solidFill>
-                  <a:schemeClr val="tx1"/>
-                </a:solidFill>
-              </a:rPr>
-              <a:t>KPI · Pending Approvals</a:t>
-            </a:r>
-            <a:endParaRPr lang="en-US" sz="1100" dirty="0"/>
-          </a:p>
-        </p:txBody>
-      </p:sp>
-      <p:sp>
-        <p:nvSpPr>
-          <p:cNvPr id="11" name="Text 8"/>
-          <p:cNvSpPr txBox="1"/>
-          <p:nvPr/>
-        </p:nvSpPr>
-        <p:spPr>
-          <a:xfrm>
-            <a:off x="6355080" y="2606040"/>
-            <a:ext cx="2331720" cy="1828800"/>
+            <a:off x="6995160" y="1645920"/>
+            <a:ext cx="1691640" cy="3017520"/>
           </a:xfrm>
           <a:prstGeom prst="rect">
             <a:avLst/>
@@ -7562,7 +8252,7 @@
                   <a:schemeClr val="tx1"/>
                 </a:solidFill>
               </a:rPr>
-              <a:t>Chart: budget vs consumed</a:t>
+              <a:t>KPI tags: Active Projects, At-Risk Budgets, Pending Approvals</a:t>
             </a:r>
             <a:endParaRPr lang="en-US" sz="1200" dirty="0"/>
           </a:p>
@@ -7580,7 +8270,7 @@
                   <a:schemeClr val="tx1"/>
                 </a:solidFill>
               </a:rPr>
-              <a:t>Filters: client, billing type, status</a:t>
+              <a:t>Chart: budget vs consumed</a:t>
             </a:r>
             <a:endParaRPr lang="en-US" sz="1200" dirty="0"/>
           </a:p>
@@ -7724,7 +8414,7 @@
                   <a:schemeClr val="tx1"/>
                 </a:solidFill>
               </a:rPr>
-              <a:t>Timesheets → approval → roll-up</a:t>
+              <a:t>Employee: log and submit hours</a:t>
             </a:r>
             <a:endParaRPr lang="en-US" sz="3000" dirty="0"/>
           </a:p>
@@ -7732,294 +8422,14 @@
       </p:sp>
       <p:sp>
         <p:nvSpPr>
-          <p:cNvPr id="3" name="step Log hours"/>
+          <p:cNvPr id="3" name="My Timesheets screenshot frame"/>
           <p:cNvSpPr/>
           <p:nvPr/>
         </p:nvSpPr>
         <p:spPr>
           <a:xfrm>
             <a:off x="457200" y="1051560"/>
-            <a:ext cx="1627632" cy="411480"/>
-          </a:xfrm>
-          <a:prstGeom prst="chevron">
-            <a:avLst/>
-          </a:prstGeom>
-          <a:solidFill>
-            <a:schemeClr val="accent1"/>
-          </a:solidFill>
-          <a:ln/>
-        </p:spPr>
-      </p:sp>
-      <p:sp>
-        <p:nvSpPr>
-          <p:cNvPr id="4" name="Text 2"/>
-          <p:cNvSpPr txBox="1"/>
-          <p:nvPr/>
-        </p:nvSpPr>
-        <p:spPr>
-          <a:xfrm>
-            <a:off x="621792" y="1051560"/>
-            <a:ext cx="1298448" cy="411480"/>
-          </a:xfrm>
-          <a:prstGeom prst="rect">
-            <a:avLst/>
-          </a:prstGeom>
-          <a:noFill/>
-          <a:ln/>
-        </p:spPr>
-        <p:txBody>
-          <a:bodyPr wrap="square" lIns="0" tIns="0" rIns="0" bIns="0" rtlCol="0" anchor="ctr"/>
-          <a:lstStyle/>
-          <a:p>
-            <a:pPr algn="ctr" indent="0" marL="0">
-              <a:buNone/>
-            </a:pPr>
-            <a:r>
-              <a:rPr lang="en-US" sz="1200" b="1" dirty="0">
-                <a:solidFill>
-                  <a:schemeClr val="bg1"/>
-                </a:solidFill>
-              </a:rPr>
-              <a:t>Log hours</a:t>
-            </a:r>
-            <a:endParaRPr lang="en-US" sz="1200" dirty="0"/>
-          </a:p>
-        </p:txBody>
-      </p:sp>
-      <p:sp>
-        <p:nvSpPr>
-          <p:cNvPr id="5" name="step Submit"/>
-          <p:cNvSpPr/>
-          <p:nvPr/>
-        </p:nvSpPr>
-        <p:spPr>
-          <a:xfrm>
-            <a:off x="2121408" y="1051560"/>
-            <a:ext cx="1627632" cy="411480"/>
-          </a:xfrm>
-          <a:prstGeom prst="chevron">
-            <a:avLst/>
-          </a:prstGeom>
-          <a:solidFill>
-            <a:schemeClr val="accent1"/>
-          </a:solidFill>
-          <a:ln/>
-        </p:spPr>
-      </p:sp>
-      <p:sp>
-        <p:nvSpPr>
-          <p:cNvPr id="6" name="Text 4"/>
-          <p:cNvSpPr txBox="1"/>
-          <p:nvPr/>
-        </p:nvSpPr>
-        <p:spPr>
-          <a:xfrm>
-            <a:off x="2286000" y="1051560"/>
-            <a:ext cx="1298448" cy="411480"/>
-          </a:xfrm>
-          <a:prstGeom prst="rect">
-            <a:avLst/>
-          </a:prstGeom>
-          <a:noFill/>
-          <a:ln/>
-        </p:spPr>
-        <p:txBody>
-          <a:bodyPr wrap="square" lIns="0" tIns="0" rIns="0" bIns="0" rtlCol="0" anchor="ctr"/>
-          <a:lstStyle/>
-          <a:p>
-            <a:pPr algn="ctr" indent="0" marL="0">
-              <a:buNone/>
-            </a:pPr>
-            <a:r>
-              <a:rPr lang="en-US" sz="1200" b="1" dirty="0">
-                <a:solidFill>
-                  <a:schemeClr val="bg1"/>
-                </a:solidFill>
-              </a:rPr>
-              <a:t>Submit</a:t>
-            </a:r>
-            <a:endParaRPr lang="en-US" sz="1200" dirty="0"/>
-          </a:p>
-        </p:txBody>
-      </p:sp>
-      <p:sp>
-        <p:nvSpPr>
-          <p:cNvPr id="7" name="step Approve"/>
-          <p:cNvSpPr/>
-          <p:nvPr/>
-        </p:nvSpPr>
-        <p:spPr>
-          <a:xfrm>
-            <a:off x="3785616" y="1051560"/>
-            <a:ext cx="1627632" cy="411480"/>
-          </a:xfrm>
-          <a:prstGeom prst="chevron">
-            <a:avLst/>
-          </a:prstGeom>
-          <a:solidFill>
-            <a:schemeClr val="accent1"/>
-          </a:solidFill>
-          <a:ln/>
-        </p:spPr>
-      </p:sp>
-      <p:sp>
-        <p:nvSpPr>
-          <p:cNvPr id="8" name="Text 6"/>
-          <p:cNvSpPr txBox="1"/>
-          <p:nvPr/>
-        </p:nvSpPr>
-        <p:spPr>
-          <a:xfrm>
-            <a:off x="3950208" y="1051560"/>
-            <a:ext cx="1298448" cy="411480"/>
-          </a:xfrm>
-          <a:prstGeom prst="rect">
-            <a:avLst/>
-          </a:prstGeom>
-          <a:noFill/>
-          <a:ln/>
-        </p:spPr>
-        <p:txBody>
-          <a:bodyPr wrap="square" lIns="0" tIns="0" rIns="0" bIns="0" rtlCol="0" anchor="ctr"/>
-          <a:lstStyle/>
-          <a:p>
-            <a:pPr algn="ctr" indent="0" marL="0">
-              <a:buNone/>
-            </a:pPr>
-            <a:r>
-              <a:rPr lang="en-US" sz="1200" b="1" dirty="0">
-                <a:solidFill>
-                  <a:schemeClr val="bg1"/>
-                </a:solidFill>
-              </a:rPr>
-              <a:t>Approve</a:t>
-            </a:r>
-            <a:endParaRPr lang="en-US" sz="1200" dirty="0"/>
-          </a:p>
-        </p:txBody>
-      </p:sp>
-      <p:sp>
-        <p:nvSpPr>
-          <p:cNvPr id="9" name="step Budget roll-up"/>
-          <p:cNvSpPr/>
-          <p:nvPr/>
-        </p:nvSpPr>
-        <p:spPr>
-          <a:xfrm>
-            <a:off x="5449824" y="1051560"/>
-            <a:ext cx="1627632" cy="411480"/>
-          </a:xfrm>
-          <a:prstGeom prst="chevron">
-            <a:avLst/>
-          </a:prstGeom>
-          <a:solidFill>
-            <a:schemeClr val="accent2"/>
-          </a:solidFill>
-          <a:ln/>
-        </p:spPr>
-      </p:sp>
-      <p:sp>
-        <p:nvSpPr>
-          <p:cNvPr id="10" name="Text 8"/>
-          <p:cNvSpPr txBox="1"/>
-          <p:nvPr/>
-        </p:nvSpPr>
-        <p:spPr>
-          <a:xfrm>
-            <a:off x="5614416" y="1051560"/>
-            <a:ext cx="1298448" cy="411480"/>
-          </a:xfrm>
-          <a:prstGeom prst="rect">
-            <a:avLst/>
-          </a:prstGeom>
-          <a:noFill/>
-          <a:ln/>
-        </p:spPr>
-        <p:txBody>
-          <a:bodyPr wrap="square" lIns="0" tIns="0" rIns="0" bIns="0" rtlCol="0" anchor="ctr"/>
-          <a:lstStyle/>
-          <a:p>
-            <a:pPr algn="ctr" indent="0" marL="0">
-              <a:buNone/>
-            </a:pPr>
-            <a:r>
-              <a:rPr lang="en-US" sz="1200" b="1" dirty="0">
-                <a:solidFill>
-                  <a:schemeClr val="tx1"/>
-                </a:solidFill>
-              </a:rPr>
-              <a:t>Budget roll-up</a:t>
-            </a:r>
-            <a:endParaRPr lang="en-US" sz="1200" dirty="0"/>
-          </a:p>
-        </p:txBody>
-      </p:sp>
-      <p:sp>
-        <p:nvSpPr>
-          <p:cNvPr id="11" name="step Alerts"/>
-          <p:cNvSpPr/>
-          <p:nvPr/>
-        </p:nvSpPr>
-        <p:spPr>
-          <a:xfrm>
-            <a:off x="7114032" y="1051560"/>
-            <a:ext cx="1627632" cy="411480"/>
-          </a:xfrm>
-          <a:prstGeom prst="chevron">
-            <a:avLst/>
-          </a:prstGeom>
-          <a:solidFill>
-            <a:schemeClr val="accent1"/>
-          </a:solidFill>
-          <a:ln/>
-        </p:spPr>
-      </p:sp>
-      <p:sp>
-        <p:nvSpPr>
-          <p:cNvPr id="12" name="Text 10"/>
-          <p:cNvSpPr txBox="1"/>
-          <p:nvPr/>
-        </p:nvSpPr>
-        <p:spPr>
-          <a:xfrm>
-            <a:off x="7278624" y="1051560"/>
-            <a:ext cx="1298448" cy="411480"/>
-          </a:xfrm>
-          <a:prstGeom prst="rect">
-            <a:avLst/>
-          </a:prstGeom>
-          <a:noFill/>
-          <a:ln/>
-        </p:spPr>
-        <p:txBody>
-          <a:bodyPr wrap="square" lIns="0" tIns="0" rIns="0" bIns="0" rtlCol="0" anchor="ctr"/>
-          <a:lstStyle/>
-          <a:p>
-            <a:pPr algn="ctr" indent="0" marL="0">
-              <a:buNone/>
-            </a:pPr>
-            <a:r>
-              <a:rPr lang="en-US" sz="1200" b="1" dirty="0">
-                <a:solidFill>
-                  <a:schemeClr val="bg1"/>
-                </a:solidFill>
-              </a:rPr>
-              <a:t>Alerts</a:t>
-            </a:r>
-            <a:endParaRPr lang="en-US" sz="1200" dirty="0"/>
-          </a:p>
-        </p:txBody>
-      </p:sp>
-      <p:sp>
-        <p:nvSpPr>
-          <p:cNvPr id="13" name="My Timesheets screenshot frame"/>
-          <p:cNvSpPr/>
-          <p:nvPr/>
-        </p:nvSpPr>
-        <p:spPr>
-          <a:xfrm>
-            <a:off x="457200" y="1691640"/>
-            <a:ext cx="3977640" cy="2386584"/>
+            <a:ext cx="6309360" cy="3611880"/>
           </a:xfrm>
           <a:prstGeom prst="rect">
             <a:avLst/>
@@ -8044,7 +8454,7 @@
       </p:sp>
       <p:pic>
         <p:nvPicPr>
-          <p:cNvPr id="14" name="My Timesheets screenshot" descr="My Timesheets screenshot">    </p:cNvPr>
+          <p:cNvPr id="4" name="My Timesheets screenshot" descr="My Timesheets screenshot">    </p:cNvPr>
           <p:cNvPicPr>
             <a:picLocks noChangeAspect="1"/>
           </p:cNvPicPr>
@@ -8058,8 +8468,8 @@
         </p:blipFill>
         <p:spPr>
           <a:xfrm>
-            <a:off x="484632" y="1719072"/>
-            <a:ext cx="3922776" cy="2331720"/>
+            <a:off x="484632" y="1078992"/>
+            <a:ext cx="6254496" cy="3557016"/>
           </a:xfrm>
           <a:prstGeom prst="rect">
             <a:avLst/>
@@ -8068,142 +8478,79 @@
       </p:pic>
       <p:sp>
         <p:nvSpPr>
-          <p:cNvPr id="15" name="Text 12"/>
-          <p:cNvSpPr txBox="1"/>
-          <p:nvPr/>
-        </p:nvSpPr>
-        <p:spPr>
-          <a:xfrm>
-            <a:off x="457200" y="4160520"/>
-            <a:ext cx="3977640" cy="274320"/>
-          </a:xfrm>
-          <a:prstGeom prst="rect">
-            <a:avLst/>
-          </a:prstGeom>
-          <a:noFill/>
-          <a:ln/>
-        </p:spPr>
-        <p:txBody>
-          <a:bodyPr wrap="square" lIns="0" tIns="0" rIns="0" bIns="0" rtlCol="0" anchor="ctr"/>
-          <a:lstStyle/>
-          <a:p>
-            <a:pPr algn="l" indent="0" marL="0">
-              <a:buNone/>
-            </a:pPr>
-            <a:r>
-              <a:rPr lang="en-US" sz="1100" i="1" dirty="0">
-                <a:solidFill>
-                  <a:schemeClr val="tx2"/>
-                </a:solidFill>
-              </a:rPr>
-              <a:t>User: daily rows, Import Hours, ≤ 24 h/day</a:t>
-            </a:r>
-            <a:endParaRPr lang="en-US" sz="1100" dirty="0"/>
-          </a:p>
-        </p:txBody>
-      </p:sp>
-      <p:sp>
-        <p:nvSpPr>
-          <p:cNvPr id="16" name="Approve Timesheets screenshot frame"/>
+          <p:cNvPr id="5" name="highlight totals and status"/>
           <p:cNvSpPr/>
           <p:nvPr/>
         </p:nvSpPr>
         <p:spPr>
           <a:xfrm>
-            <a:off x="4709160" y="1691640"/>
-            <a:ext cx="3977640" cy="1645920"/>
-          </a:xfrm>
-          <a:prstGeom prst="rect">
-            <a:avLst/>
+            <a:off x="3091623" y="1788209"/>
+            <a:ext cx="1640946" cy="313463"/>
+          </a:xfrm>
+          <a:prstGeom prst="roundRect">
+            <a:avLst>
+              <a:gd name="adj" fmla="val 17503"/>
+            </a:avLst>
           </a:prstGeom>
           <a:solidFill>
-            <a:schemeClr val="bg1"/>
+            <a:schemeClr val="bg1">
+              <a:alpha val="0"/>
+            </a:schemeClr>
           </a:solidFill>
-          <a:ln w="12700">
+          <a:ln w="31750">
             <a:solidFill>
-              <a:schemeClr val="bg2"/>
+              <a:schemeClr val="accent2"/>
             </a:solidFill>
             <a:prstDash val="solid"/>
           </a:ln>
-          <a:effectLst>
-            <a:outerShdw sx="100000" sy="100000" kx="0" ky="0" algn="bl" rotWithShape="0" blurRad="101600" dist="25400" dir="5400000">
-              <a:srgbClr val="000000">
-                <a:alpha val="22000"/>
-              </a:srgbClr>
-            </a:outerShdw>
-          </a:effectLst>
-        </p:spPr>
-      </p:sp>
-      <p:pic>
-        <p:nvPicPr>
-          <p:cNvPr id="17" name="Approve Timesheets screenshot" descr="Approve Timesheets screenshot">    </p:cNvPr>
-          <p:cNvPicPr>
-            <a:picLocks noChangeAspect="1"/>
-          </p:cNvPicPr>
-          <p:nvPr/>
-        </p:nvPicPr>
-        <p:blipFill>
-          <a:blip r:embed="rId2"/>
-          <a:stretch>
-            <a:fillRect/>
-          </a:stretch>
-        </p:blipFill>
-        <p:spPr>
-          <a:xfrm>
-            <a:off x="4736592" y="1719072"/>
-            <a:ext cx="3922776" cy="1591056"/>
-          </a:xfrm>
-          <a:prstGeom prst="rect">
-            <a:avLst/>
-          </a:prstGeom>
-        </p:spPr>
-      </p:pic>
-      <p:sp>
-        <p:nvSpPr>
-          <p:cNvPr id="18" name="Text 14"/>
+        </p:spPr>
+      </p:sp>
+      <p:sp>
+        <p:nvSpPr>
+          <p:cNvPr id="6" name="Text 3"/>
           <p:cNvSpPr txBox="1"/>
           <p:nvPr/>
         </p:nvSpPr>
         <p:spPr>
           <a:xfrm>
-            <a:off x="4709160" y="3429000"/>
-            <a:ext cx="3977640" cy="274320"/>
-          </a:xfrm>
-          <a:prstGeom prst="rect">
-            <a:avLst/>
-          </a:prstGeom>
-          <a:noFill/>
-          <a:ln/>
-        </p:spPr>
-        <p:txBody>
-          <a:bodyPr wrap="square" lIns="0" tIns="0" rIns="0" bIns="0" rtlCol="0" anchor="ctr"/>
-          <a:lstStyle/>
-          <a:p>
-            <a:pPr algn="l" indent="0" marL="0">
-              <a:buNone/>
-            </a:pPr>
-            <a:r>
-              <a:rPr lang="en-US" sz="1100" i="1" dirty="0">
-                <a:solidFill>
-                  <a:schemeClr val="tx2"/>
-                </a:solidFill>
-              </a:rPr>
-              <a:t>Admin: Approve / Reject in the header or the list</a:t>
-            </a:r>
-            <a:endParaRPr lang="en-US" sz="1100" dirty="0"/>
-          </a:p>
-        </p:txBody>
-      </p:sp>
-      <p:sp>
-        <p:nvSpPr>
-          <p:cNvPr id="19" name="Text 15"/>
+            <a:off x="6995160" y="1051560"/>
+            <a:ext cx="1691640" cy="548640"/>
+          </a:xfrm>
+          <a:prstGeom prst="rect">
+            <a:avLst/>
+          </a:prstGeom>
+          <a:noFill/>
+          <a:ln/>
+        </p:spPr>
+        <p:txBody>
+          <a:bodyPr wrap="square" lIns="0" tIns="0" rIns="0" bIns="0" rtlCol="0" anchor="t"/>
+          <a:lstStyle/>
+          <a:p>
+            <a:pPr indent="0" marL="0">
+              <a:buNone/>
+            </a:pPr>
+            <a:r>
+              <a:rPr lang="en-US" sz="1400" b="1" dirty="0">
+                <a:solidFill>
+                  <a:schemeClr val="accent1"/>
+                </a:solidFill>
+              </a:rPr>
+              <a:t>My Timesheets</a:t>
+            </a:r>
+            <a:endParaRPr lang="en-US" sz="1400" dirty="0"/>
+          </a:p>
+        </p:txBody>
+      </p:sp>
+      <p:sp>
+        <p:nvSpPr>
+          <p:cNvPr id="7" name="Text 4"/>
           <p:cNvSpPr txBox="1"/>
           <p:nvPr/>
         </p:nvSpPr>
         <p:spPr>
           <a:xfrm>
-            <a:off x="4709160" y="3794760"/>
-            <a:ext cx="3977640" cy="822960"/>
+            <a:off x="6995160" y="1645920"/>
+            <a:ext cx="1691640" cy="3017520"/>
           </a:xfrm>
           <a:prstGeom prst="rect">
             <a:avLst/>
@@ -8228,7 +8575,7 @@
                   <a:schemeClr val="tx1"/>
                 </a:solidFill>
               </a:rPr>
-              <a:t>Hours update task, milestone, project, budget at once</a:t>
+              <a:t>Create week, add daily rows (task, hours, billable)</a:t>
             </a:r>
             <a:endParaRPr lang="en-US" sz="1200" dirty="0"/>
           </a:p>
@@ -8246,7 +8593,43 @@
                   <a:schemeClr val="tx1"/>
                 </a:solidFill>
               </a:rPr>
-              <a:t>One alert per threshold crossing</a:t>
+              <a:t>Save → Submit for Approval</a:t>
+            </a:r>
+            <a:endParaRPr lang="en-US" sz="1200" dirty="0"/>
+          </a:p>
+          <a:p>
+            <a:pPr marL="177800" indent="-177800">
+              <a:spcAft>
+                <a:spcPts val="800"/>
+              </a:spcAft>
+              <a:buSzPct val="100000"/>
+              <a:buChar char="•"/>
+            </a:pPr>
+            <a:r>
+              <a:rPr lang="en-US" sz="1200" dirty="0">
+                <a:solidFill>
+                  <a:schemeClr val="tx1"/>
+                </a:solidFill>
+              </a:rPr>
+              <a:t>Locked after submit</a:t>
+            </a:r>
+            <a:endParaRPr lang="en-US" sz="1200" dirty="0"/>
+          </a:p>
+          <a:p>
+            <a:pPr marL="177800" indent="-177800">
+              <a:spcAft>
+                <a:spcPts val="800"/>
+              </a:spcAft>
+              <a:buSzPct val="100000"/>
+              <a:buChar char="•"/>
+            </a:pPr>
+            <a:r>
+              <a:rPr lang="en-US" sz="1200" dirty="0">
+                <a:solidFill>
+                  <a:schemeClr val="tx1"/>
+                </a:solidFill>
+              </a:rPr>
+              <a:t>Import Hours from a tracker</a:t>
             </a:r>
             <a:endParaRPr lang="en-US" sz="1200" dirty="0"/>
           </a:p>
@@ -8354,7 +8737,7 @@
                   <a:schemeClr val="tx1"/>
                 </a:solidFill>
               </a:rPr>
-              <a:t>Projects – budget, milestones, tasks</a:t>
+              <a:t>Manager: approve or reject</a:t>
             </a:r>
             <a:endParaRPr lang="en-US" sz="3000" dirty="0"/>
           </a:p>
@@ -8362,126 +8745,14 @@
       </p:sp>
       <p:sp>
         <p:nvSpPr>
-          <p:cNvPr id="3" name="Text 1"/>
-          <p:cNvSpPr txBox="1"/>
-          <p:nvPr/>
-        </p:nvSpPr>
-        <p:spPr>
-          <a:xfrm>
-            <a:off x="457200" y="1188720"/>
-            <a:ext cx="2834640" cy="3291840"/>
-          </a:xfrm>
-          <a:prstGeom prst="rect">
-            <a:avLst/>
-          </a:prstGeom>
-          <a:noFill/>
-          <a:ln/>
-        </p:spPr>
-        <p:txBody>
-          <a:bodyPr wrap="square" lIns="0" tIns="0" rIns="0" bIns="0" rtlCol="0" anchor="t"/>
-          <a:lstStyle/>
-          <a:p>
-            <a:pPr marL="177800" indent="-177800">
-              <a:spcAft>
-                <a:spcPts val="800"/>
-              </a:spcAft>
-              <a:buSzPct val="100000"/>
-              <a:buChar char="•"/>
-            </a:pPr>
-            <a:r>
-              <a:rPr lang="en-US" sz="1300" dirty="0">
-                <a:solidFill>
-                  <a:schemeClr val="tx1"/>
-                </a:solidFill>
-              </a:rPr>
-              <a:t>Edit project + budget + milestones + tasks in one draft</a:t>
-            </a:r>
-            <a:endParaRPr lang="en-US" sz="1300" dirty="0"/>
-          </a:p>
-          <a:p>
-            <a:pPr marL="177800" indent="-177800">
-              <a:spcAft>
-                <a:spcPts val="800"/>
-              </a:spcAft>
-              <a:buSzPct val="100000"/>
-              <a:buChar char="•"/>
-            </a:pPr>
-            <a:r>
-              <a:rPr lang="en-US" sz="1300" dirty="0">
-                <a:solidFill>
-                  <a:schemeClr val="tx1"/>
-                </a:solidFill>
-              </a:rPr>
-              <a:t>Budget used &amp; hours used progress bars</a:t>
-            </a:r>
-            <a:endParaRPr lang="en-US" sz="1300" dirty="0"/>
-          </a:p>
-          <a:p>
-            <a:pPr marL="177800" indent="-177800">
-              <a:spcAft>
-                <a:spcPts val="800"/>
-              </a:spcAft>
-              <a:buSzPct val="100000"/>
-              <a:buChar char="•"/>
-            </a:pPr>
-            <a:r>
-              <a:rPr lang="en-US" sz="1300" dirty="0">
-                <a:solidFill>
-                  <a:schemeClr val="tx1"/>
-                </a:solidFill>
-              </a:rPr>
-              <a:t>Burn rate and projected completion</a:t>
-            </a:r>
-            <a:endParaRPr lang="en-US" sz="1300" dirty="0"/>
-          </a:p>
-          <a:p>
-            <a:pPr marL="177800" indent="-177800">
-              <a:spcAft>
-                <a:spcPts val="800"/>
-              </a:spcAft>
-              <a:buSzPct val="100000"/>
-              <a:buChar char="•"/>
-            </a:pPr>
-            <a:r>
-              <a:rPr lang="en-US" sz="1300" dirty="0">
-                <a:solidFill>
-                  <a:schemeClr val="tx1"/>
-                </a:solidFill>
-              </a:rPr>
-              <a:t>Tabs: timesheets, alerts, invoices, change log</a:t>
-            </a:r>
-            <a:endParaRPr lang="en-US" sz="1300" dirty="0"/>
-          </a:p>
-          <a:p>
-            <a:pPr marL="177800" indent="-177800">
-              <a:spcAft>
-                <a:spcPts val="800"/>
-              </a:spcAft>
-              <a:buSzPct val="100000"/>
-              <a:buChar char="•"/>
-            </a:pPr>
-            <a:r>
-              <a:rPr lang="en-US" sz="1300" dirty="0">
-                <a:solidFill>
-                  <a:schemeClr val="tx1"/>
-                </a:solidFill>
-              </a:rPr>
-              <a:t>Recalculate Budget action</a:t>
-            </a:r>
-            <a:endParaRPr lang="en-US" sz="1300" dirty="0"/>
-          </a:p>
-        </p:txBody>
-      </p:sp>
-      <p:sp>
-        <p:nvSpPr>
-          <p:cNvPr id="4" name="Projects screenshot frame"/>
+          <p:cNvPr id="3" name="Approve Timesheets screenshot frame"/>
           <p:cNvSpPr/>
           <p:nvPr/>
         </p:nvSpPr>
         <p:spPr>
           <a:xfrm>
-            <a:off x="3520440" y="1097280"/>
-            <a:ext cx="5166360" cy="3099816"/>
+            <a:off x="457200" y="1051560"/>
+            <a:ext cx="6309360" cy="3611880"/>
           </a:xfrm>
           <a:prstGeom prst="rect">
             <a:avLst/>
@@ -8506,7 +8777,7 @@
       </p:sp>
       <p:pic>
         <p:nvPicPr>
-          <p:cNvPr id="5" name="Projects screenshot" descr="Projects screenshot">    </p:cNvPr>
+          <p:cNvPr id="4" name="Approve Timesheets screenshot" descr="Approve Timesheets screenshot">    </p:cNvPr>
           <p:cNvPicPr>
             <a:picLocks noChangeAspect="1"/>
           </p:cNvPicPr>
@@ -8520,14 +8791,43 @@
         </p:blipFill>
         <p:spPr>
           <a:xfrm>
-            <a:off x="3547872" y="1124712"/>
-            <a:ext cx="5111496" cy="3044952"/>
+            <a:off x="484632" y="1078992"/>
+            <a:ext cx="6254496" cy="3557016"/>
           </a:xfrm>
           <a:prstGeom prst="rect">
             <a:avLst/>
           </a:prstGeom>
         </p:spPr>
       </p:pic>
+      <p:sp>
+        <p:nvSpPr>
+          <p:cNvPr id="5" name="highlight Approve and Reject buttons"/>
+          <p:cNvSpPr/>
+          <p:nvPr/>
+        </p:nvSpPr>
+        <p:spPr>
+          <a:xfrm>
+            <a:off x="5753953" y="1502321"/>
+            <a:ext cx="656905" cy="209881"/>
+          </a:xfrm>
+          <a:prstGeom prst="roundRect">
+            <a:avLst>
+              <a:gd name="adj" fmla="val 26141"/>
+            </a:avLst>
+          </a:prstGeom>
+          <a:solidFill>
+            <a:schemeClr val="bg1">
+              <a:alpha val="0"/>
+            </a:schemeClr>
+          </a:solidFill>
+          <a:ln w="31750">
+            <a:solidFill>
+              <a:schemeClr val="accent2"/>
+            </a:solidFill>
+            <a:prstDash val="solid"/>
+          </a:ln>
+        </p:spPr>
+      </p:sp>
       <p:sp>
         <p:nvSpPr>
           <p:cNvPr id="6" name="Text 3"/>
@@ -8536,31 +8836,125 @@
         </p:nvSpPr>
         <p:spPr>
           <a:xfrm>
-            <a:off x="3520440" y="4279392"/>
-            <a:ext cx="5166360" cy="274320"/>
-          </a:xfrm>
-          <a:prstGeom prst="rect">
-            <a:avLst/>
-          </a:prstGeom>
-          <a:noFill/>
-          <a:ln/>
-        </p:spPr>
-        <p:txBody>
-          <a:bodyPr wrap="square" lIns="0" tIns="0" rIns="0" bIns="0" rtlCol="0" anchor="ctr"/>
-          <a:lstStyle/>
-          <a:p>
-            <a:pPr algn="l" indent="0" marL="0">
-              <a:buNone/>
-            </a:pPr>
-            <a:r>
-              <a:rPr lang="en-US" sz="1100" i="1" dirty="0">
-                <a:solidFill>
-                  <a:schemeClr val="tx2"/>
-                </a:solidFill>
-              </a:rPr>
-              <a:t>List and details side by side (flexible column layout)</a:t>
-            </a:r>
-            <a:endParaRPr lang="en-US" sz="1100" dirty="0"/>
+            <a:off x="6995160" y="1051560"/>
+            <a:ext cx="1691640" cy="548640"/>
+          </a:xfrm>
+          <a:prstGeom prst="rect">
+            <a:avLst/>
+          </a:prstGeom>
+          <a:noFill/>
+          <a:ln/>
+        </p:spPr>
+        <p:txBody>
+          <a:bodyPr wrap="square" lIns="0" tIns="0" rIns="0" bIns="0" rtlCol="0" anchor="t"/>
+          <a:lstStyle/>
+          <a:p>
+            <a:pPr indent="0" marL="0">
+              <a:buNone/>
+            </a:pPr>
+            <a:r>
+              <a:rPr lang="en-US" sz="1400" b="1" dirty="0">
+                <a:solidFill>
+                  <a:schemeClr val="accent1"/>
+                </a:solidFill>
+              </a:rPr>
+              <a:t>Approve Timesheets</a:t>
+            </a:r>
+            <a:endParaRPr lang="en-US" sz="1400" dirty="0"/>
+          </a:p>
+        </p:txBody>
+      </p:sp>
+      <p:sp>
+        <p:nvSpPr>
+          <p:cNvPr id="7" name="Text 4"/>
+          <p:cNvSpPr txBox="1"/>
+          <p:nvPr/>
+        </p:nvSpPr>
+        <p:spPr>
+          <a:xfrm>
+            <a:off x="6995160" y="1645920"/>
+            <a:ext cx="1691640" cy="3017520"/>
+          </a:xfrm>
+          <a:prstGeom prst="rect">
+            <a:avLst/>
+          </a:prstGeom>
+          <a:noFill/>
+          <a:ln/>
+        </p:spPr>
+        <p:txBody>
+          <a:bodyPr wrap="square" lIns="0" tIns="0" rIns="0" bIns="0" rtlCol="0" anchor="t"/>
+          <a:lstStyle/>
+          <a:p>
+            <a:pPr marL="177800" indent="-177800">
+              <a:spcAft>
+                <a:spcPts val="800"/>
+              </a:spcAft>
+              <a:buSzPct val="100000"/>
+              <a:buChar char="•"/>
+            </a:pPr>
+            <a:r>
+              <a:rPr lang="en-US" sz="1200" dirty="0">
+                <a:solidFill>
+                  <a:schemeClr val="tx1"/>
+                </a:solidFill>
+              </a:rPr>
+              <a:t>List opens with Submitted weeks</a:t>
+            </a:r>
+            <a:endParaRPr lang="en-US" sz="1200" dirty="0"/>
+          </a:p>
+          <a:p>
+            <a:pPr marL="177800" indent="-177800">
+              <a:spcAft>
+                <a:spcPts val="800"/>
+              </a:spcAft>
+              <a:buSzPct val="100000"/>
+              <a:buChar char="•"/>
+            </a:pPr>
+            <a:r>
+              <a:rPr lang="en-US" sz="1200" dirty="0">
+                <a:solidFill>
+                  <a:schemeClr val="tx1"/>
+                </a:solidFill>
+              </a:rPr>
+              <a:t>Open a week → Approve / Reject</a:t>
+            </a:r>
+            <a:endParaRPr lang="en-US" sz="1200" dirty="0"/>
+          </a:p>
+          <a:p>
+            <a:pPr marL="177800" indent="-177800">
+              <a:spcAft>
+                <a:spcPts val="800"/>
+              </a:spcAft>
+              <a:buSzPct val="100000"/>
+              <a:buChar char="•"/>
+            </a:pPr>
+            <a:r>
+              <a:rPr lang="en-US" sz="1200" dirty="0">
+                <a:solidFill>
+                  <a:schemeClr val="tx1"/>
+                </a:solidFill>
+              </a:rPr>
+              <a:t>Reject needs a reason</a:t>
+            </a:r>
+            <a:endParaRPr lang="en-US" sz="1200" dirty="0"/>
+          </a:p>
+          <a:p>
+            <a:pPr marL="177800" indent="-177800">
+              <a:spcAft>
+                <a:spcPts val="800"/>
+              </a:spcAft>
+              <a:buSzPct val="100000"/>
+              <a:buChar char="•"/>
+            </a:pPr>
+            <a:r>
+              <a:rPr lang="en-US" sz="1200" dirty="0">
+                <a:solidFill>
+                  <a:schemeClr val="tx1"/>
+                </a:solidFill>
+              </a:rPr>
+              <a:t>Approval updates the budget at once</a:t>
+            </a:r>
+            <a:endParaRPr lang="en-US" sz="1200" dirty="0"/>
           </a:p>
         </p:txBody>
       </p:sp>
@@ -8666,7 +9060,7 @@
                   <a:schemeClr val="tx1"/>
                 </a:solidFill>
               </a:rPr>
-              <a:t>Billing Workbench, settings and audit</a:t>
+              <a:t>Projects: budget, milestones, tasks</a:t>
             </a:r>
             <a:endParaRPr lang="en-US" sz="3000" dirty="0"/>
           </a:p>
@@ -8674,14 +9068,14 @@
       </p:sp>
       <p:sp>
         <p:nvSpPr>
-          <p:cNvPr id="3" name="Billing Workbench screenshot frame"/>
+          <p:cNvPr id="3" name="Projects screenshot frame"/>
           <p:cNvSpPr/>
           <p:nvPr/>
         </p:nvSpPr>
         <p:spPr>
           <a:xfrm>
-            <a:off x="457200" y="1097280"/>
-            <a:ext cx="5029200" cy="3017520"/>
+            <a:off x="457200" y="1051560"/>
+            <a:ext cx="6309360" cy="3611880"/>
           </a:xfrm>
           <a:prstGeom prst="rect">
             <a:avLst/>
@@ -8706,7 +9100,7 @@
       </p:sp>
       <p:pic>
         <p:nvPicPr>
-          <p:cNvPr id="4" name="Billing Workbench screenshot" descr="Billing Workbench screenshot">    </p:cNvPr>
+          <p:cNvPr id="4" name="Projects screenshot" descr="Projects screenshot">    </p:cNvPr>
           <p:cNvPicPr>
             <a:picLocks noChangeAspect="1"/>
           </p:cNvPicPr>
@@ -8720,8 +9114,8 @@
         </p:blipFill>
         <p:spPr>
           <a:xfrm>
-            <a:off x="484632" y="1124712"/>
-            <a:ext cx="4974336" cy="2962656"/>
+            <a:off x="484632" y="1078992"/>
+            <a:ext cx="6254496" cy="3557016"/>
           </a:xfrm>
           <a:prstGeom prst="rect">
             <a:avLst/>
@@ -8730,61 +9124,68 @@
       </p:pic>
       <p:sp>
         <p:nvSpPr>
-          <p:cNvPr id="5" name="Text 2"/>
-          <p:cNvSpPr txBox="1"/>
-          <p:nvPr/>
-        </p:nvSpPr>
-        <p:spPr>
-          <a:xfrm>
-            <a:off x="457200" y="4206240"/>
-            <a:ext cx="5029200" cy="274320"/>
-          </a:xfrm>
-          <a:prstGeom prst="rect">
-            <a:avLst/>
-          </a:prstGeom>
-          <a:noFill/>
-          <a:ln/>
-        </p:spPr>
-        <p:txBody>
-          <a:bodyPr wrap="square" lIns="0" tIns="0" rIns="0" bIns="0" rtlCol="0" anchor="ctr"/>
-          <a:lstStyle/>
-          <a:p>
-            <a:pPr algn="l" indent="0" marL="0">
-              <a:buNone/>
-            </a:pPr>
-            <a:r>
-              <a:rPr lang="en-US" sz="1100" i="1" dirty="0">
-                <a:solidFill>
-                  <a:schemeClr val="tx2"/>
-                </a:solidFill>
-              </a:rPr>
-              <a:t>KPIs: Unbilled Hours · Draft Invoices · Overdue Amount</a:t>
-            </a:r>
-            <a:endParaRPr lang="en-US" sz="1100" dirty="0"/>
-          </a:p>
-        </p:txBody>
-      </p:sp>
-      <p:sp>
-        <p:nvSpPr>
-          <p:cNvPr id="6" name="pill Draft"/>
+          <p:cNvPr id="5" name="highlight budget header"/>
           <p:cNvSpPr/>
           <p:nvPr/>
         </p:nvSpPr>
         <p:spPr>
           <a:xfrm>
-            <a:off x="5806440" y="1143000"/>
-            <a:ext cx="822960" cy="329184"/>
+            <a:off x="3950574" y="1767492"/>
+            <a:ext cx="2574950" cy="466765"/>
           </a:xfrm>
           <a:prstGeom prst="roundRect">
             <a:avLst>
-              <a:gd name="adj" fmla="val 50000"/>
+              <a:gd name="adj" fmla="val 11754"/>
             </a:avLst>
           </a:prstGeom>
           <a:solidFill>
-            <a:schemeClr val="tx2"/>
+            <a:schemeClr val="bg1">
+              <a:alpha val="0"/>
+            </a:schemeClr>
           </a:solidFill>
-          <a:ln/>
-        </p:spPr>
+          <a:ln w="31750">
+            <a:solidFill>
+              <a:schemeClr val="accent2"/>
+            </a:solidFill>
+            <a:prstDash val="solid"/>
+          </a:ln>
+        </p:spPr>
+      </p:sp>
+      <p:sp>
+        <p:nvSpPr>
+          <p:cNvPr id="6" name="Text 3"/>
+          <p:cNvSpPr txBox="1"/>
+          <p:nvPr/>
+        </p:nvSpPr>
+        <p:spPr>
+          <a:xfrm>
+            <a:off x="6995160" y="1051560"/>
+            <a:ext cx="1691640" cy="548640"/>
+          </a:xfrm>
+          <a:prstGeom prst="rect">
+            <a:avLst/>
+          </a:prstGeom>
+          <a:noFill/>
+          <a:ln/>
+        </p:spPr>
+        <p:txBody>
+          <a:bodyPr wrap="square" lIns="0" tIns="0" rIns="0" bIns="0" rtlCol="0" anchor="t"/>
+          <a:lstStyle/>
+          <a:p>
+            <a:pPr indent="0" marL="0">
+              <a:buNone/>
+            </a:pPr>
+            <a:r>
+              <a:rPr lang="en-US" sz="1400" b="1" dirty="0">
+                <a:solidFill>
+                  <a:schemeClr val="accent1"/>
+                </a:solidFill>
+              </a:rPr>
+              <a:t>Budget health live</a:t>
+            </a:r>
+            <a:endParaRPr lang="en-US" sz="1400" dirty="0"/>
+          </a:p>
+        </p:txBody>
       </p:sp>
       <p:sp>
         <p:nvSpPr>
@@ -8794,208 +9195,8 @@
         </p:nvSpPr>
         <p:spPr>
           <a:xfrm>
-            <a:off x="5806440" y="1143000"/>
-            <a:ext cx="822960" cy="329184"/>
-          </a:xfrm>
-          <a:prstGeom prst="rect">
-            <a:avLst/>
-          </a:prstGeom>
-          <a:noFill/>
-          <a:ln/>
-        </p:spPr>
-        <p:txBody>
-          <a:bodyPr wrap="square" lIns="0" tIns="0" rIns="0" bIns="0" rtlCol="0" anchor="ctr"/>
-          <a:lstStyle/>
-          <a:p>
-            <a:pPr algn="ctr" indent="0" marL="0">
-              <a:buNone/>
-            </a:pPr>
-            <a:r>
-              <a:rPr lang="en-US" sz="1200" b="1" dirty="0">
-                <a:solidFill>
-                  <a:schemeClr val="bg1"/>
-                </a:solidFill>
-              </a:rPr>
-              <a:t>Draft</a:t>
-            </a:r>
-            <a:endParaRPr lang="en-US" sz="1200" dirty="0"/>
-          </a:p>
-        </p:txBody>
-      </p:sp>
-      <p:sp>
-        <p:nvSpPr>
-          <p:cNvPr id="8" name="arrow"/>
-          <p:cNvSpPr/>
-          <p:nvPr/>
-        </p:nvSpPr>
-        <p:spPr>
-          <a:xfrm>
-            <a:off x="6638544" y="1307592"/>
-            <a:ext cx="137160" cy="0"/>
-          </a:xfrm>
-          <a:prstGeom prst="line">
-            <a:avLst/>
-          </a:prstGeom>
-          <a:noFill/>
-          <a:ln w="19050">
-            <a:solidFill>
-              <a:schemeClr val="tx2"/>
-            </a:solidFill>
-            <a:prstDash val="solid"/>
-            <a:tailEnd type="triangle"/>
-          </a:ln>
-        </p:spPr>
-      </p:sp>
-      <p:sp>
-        <p:nvSpPr>
-          <p:cNvPr id="9" name="pill Issued"/>
-          <p:cNvSpPr/>
-          <p:nvPr/>
-        </p:nvSpPr>
-        <p:spPr>
-          <a:xfrm>
-            <a:off x="6784848" y="1143000"/>
-            <a:ext cx="822960" cy="329184"/>
-          </a:xfrm>
-          <a:prstGeom prst="roundRect">
-            <a:avLst>
-              <a:gd name="adj" fmla="val 50000"/>
-            </a:avLst>
-          </a:prstGeom>
-          <a:solidFill>
-            <a:schemeClr val="accent2"/>
-          </a:solidFill>
-          <a:ln/>
-        </p:spPr>
-      </p:sp>
-      <p:sp>
-        <p:nvSpPr>
-          <p:cNvPr id="10" name="Text 7"/>
-          <p:cNvSpPr txBox="1"/>
-          <p:nvPr/>
-        </p:nvSpPr>
-        <p:spPr>
-          <a:xfrm>
-            <a:off x="6784848" y="1143000"/>
-            <a:ext cx="822960" cy="329184"/>
-          </a:xfrm>
-          <a:prstGeom prst="rect">
-            <a:avLst/>
-          </a:prstGeom>
-          <a:noFill/>
-          <a:ln/>
-        </p:spPr>
-        <p:txBody>
-          <a:bodyPr wrap="square" lIns="0" tIns="0" rIns="0" bIns="0" rtlCol="0" anchor="ctr"/>
-          <a:lstStyle/>
-          <a:p>
-            <a:pPr algn="ctr" indent="0" marL="0">
-              <a:buNone/>
-            </a:pPr>
-            <a:r>
-              <a:rPr lang="en-US" sz="1200" b="1" dirty="0">
-                <a:solidFill>
-                  <a:schemeClr val="tx1"/>
-                </a:solidFill>
-              </a:rPr>
-              <a:t>Issued</a:t>
-            </a:r>
-            <a:endParaRPr lang="en-US" sz="1200" dirty="0"/>
-          </a:p>
-        </p:txBody>
-      </p:sp>
-      <p:sp>
-        <p:nvSpPr>
-          <p:cNvPr id="11" name="arrow"/>
-          <p:cNvSpPr/>
-          <p:nvPr/>
-        </p:nvSpPr>
-        <p:spPr>
-          <a:xfrm>
-            <a:off x="7616952" y="1307592"/>
-            <a:ext cx="137160" cy="0"/>
-          </a:xfrm>
-          <a:prstGeom prst="line">
-            <a:avLst/>
-          </a:prstGeom>
-          <a:noFill/>
-          <a:ln w="19050">
-            <a:solidFill>
-              <a:schemeClr val="tx2"/>
-            </a:solidFill>
-            <a:prstDash val="solid"/>
-            <a:tailEnd type="triangle"/>
-          </a:ln>
-        </p:spPr>
-      </p:sp>
-      <p:sp>
-        <p:nvSpPr>
-          <p:cNvPr id="12" name="pill Paid"/>
-          <p:cNvSpPr/>
-          <p:nvPr/>
-        </p:nvSpPr>
-        <p:spPr>
-          <a:xfrm>
-            <a:off x="7763256" y="1143000"/>
-            <a:ext cx="822960" cy="329184"/>
-          </a:xfrm>
-          <a:prstGeom prst="roundRect">
-            <a:avLst>
-              <a:gd name="adj" fmla="val 50000"/>
-            </a:avLst>
-          </a:prstGeom>
-          <a:solidFill>
-            <a:schemeClr val="accent3"/>
-          </a:solidFill>
-          <a:ln/>
-        </p:spPr>
-      </p:sp>
-      <p:sp>
-        <p:nvSpPr>
-          <p:cNvPr id="13" name="Text 10"/>
-          <p:cNvSpPr txBox="1"/>
-          <p:nvPr/>
-        </p:nvSpPr>
-        <p:spPr>
-          <a:xfrm>
-            <a:off x="7763256" y="1143000"/>
-            <a:ext cx="822960" cy="329184"/>
-          </a:xfrm>
-          <a:prstGeom prst="rect">
-            <a:avLst/>
-          </a:prstGeom>
-          <a:noFill/>
-          <a:ln/>
-        </p:spPr>
-        <p:txBody>
-          <a:bodyPr wrap="square" lIns="0" tIns="0" rIns="0" bIns="0" rtlCol="0" anchor="ctr"/>
-          <a:lstStyle/>
-          <a:p>
-            <a:pPr algn="ctr" indent="0" marL="0">
-              <a:buNone/>
-            </a:pPr>
-            <a:r>
-              <a:rPr lang="en-US" sz="1200" b="1" dirty="0">
-                <a:solidFill>
-                  <a:schemeClr val="bg1"/>
-                </a:solidFill>
-              </a:rPr>
-              <a:t>Paid</a:t>
-            </a:r>
-            <a:endParaRPr lang="en-US" sz="1200" dirty="0"/>
-          </a:p>
-        </p:txBody>
-      </p:sp>
-      <p:sp>
-        <p:nvSpPr>
-          <p:cNvPr id="14" name="Text 11"/>
-          <p:cNvSpPr txBox="1"/>
-          <p:nvPr/>
-        </p:nvSpPr>
-        <p:spPr>
-          <a:xfrm>
-            <a:off x="5806440" y="1737360"/>
-            <a:ext cx="2880360" cy="2743200"/>
+            <a:off x="6995160" y="1645920"/>
+            <a:ext cx="1691640" cy="3017520"/>
           </a:xfrm>
           <a:prstGeom prst="rect">
             <a:avLst/>
@@ -9020,7 +9221,7 @@
                   <a:schemeClr val="tx1"/>
                 </a:solidFill>
               </a:rPr>
-              <a:t>Cancel → hours billable again</a:t>
+              <a:t>Budget used, hours used, status, remaining</a:t>
             </a:r>
             <a:endParaRPr lang="en-US" sz="1200" dirty="0"/>
           </a:p>
@@ -9038,7 +9239,7 @@
                   <a:schemeClr val="tx1"/>
                 </a:solidFill>
               </a:rPr>
-              <a:t>Overdue = issued and past due</a:t>
+              <a:t>Burn rate and projected end</a:t>
             </a:r>
             <a:endParaRPr lang="en-US" sz="1200" dirty="0"/>
           </a:p>
@@ -9056,7 +9257,7 @@
                   <a:schemeClr val="tx1"/>
                 </a:solidFill>
               </a:rPr>
-              <a:t>T&amp;M · Fixed (capped) · Retainer</a:t>
+              <a:t>Tabs: milestones, timesheets, alerts, invoices</a:t>
             </a:r>
             <a:endParaRPr lang="en-US" sz="1200" dirty="0"/>
           </a:p>
@@ -9074,25 +9275,7 @@
                   <a:schemeClr val="tx1"/>
                 </a:solidFill>
               </a:rPr>
-              <a:t>Tax % and payment days in Settings</a:t>
-            </a:r>
-            <a:endParaRPr lang="en-US" sz="1200" dirty="0"/>
-          </a:p>
-          <a:p>
-            <a:pPr marL="177800" indent="-177800">
-              <a:spcAft>
-                <a:spcPts val="800"/>
-              </a:spcAft>
-              <a:buSzPct val="100000"/>
-              <a:buChar char="•"/>
-            </a:pPr>
-            <a:r>
-              <a:rPr lang="en-US" sz="1200" dirty="0">
-                <a:solidFill>
-                  <a:schemeClr val="tx1"/>
-                </a:solidFill>
-              </a:rPr>
-              <a:t>Every change in the Audit Log</a:t>
+              <a:t>Recalculate Budget</a:t>
             </a:r>
             <a:endParaRPr lang="en-US" sz="1200" dirty="0"/>
           </a:p>

</xml_diff>

<commit_message>
Fix deployment: restore working server config and app URL
- package.json: db hana + auth xsuaa always (as in the last working release);
  the deployed server no longer depends on a [production] profile / NODE_ENV and
  can never fall back to SQLite or mocked users. Local run and tests use the
  [test] profile (npm run watch, npm test)
- mta.yaml: approuter module named psa-application again, so the public URL is
  the same as before (keep-existing-routes)
- xs-security.json: back to the last working version
- docs, PDFs and slides updated
</commit_message>
<xml_diff>
--- a/docs/PSA_Project_Overview.pptx
+++ b/docs/PSA_Project_Overview.pptx
@@ -118,20 +118,20 @@
   <p:extLst>
     <p:ext uri="{521415D9-36F7-43E2-AB2F-B90AF26B5E84}">
       <p14:sectionLst xmlns:p14="http://schemas.microsoft.com/office/powerpoint/2010/main">
-        <p14:section name="Overview" id="{3f036819-7c25-0bb8-46df-ec839bf14553}">
+        <p14:section name="Overview" id="{0cf2f2b9-a902-a06f-0e14-de1a8688dfad}">
           <p14:sldIdLst>
             <p14:sldId id="256"/>
             <p14:sldId id="257"/>
           </p14:sldIdLst>
         </p14:section>
-        <p14:section name="Solution" id="{6a6d951e-049c-fa1a-00cf-45d2de8ce90a}">
+        <p14:section name="Solution" id="{748cd657-ecf5-f681-654f-967eb92fea83}">
           <p14:sldIdLst>
             <p14:sldId id="258"/>
             <p14:sldId id="259"/>
             <p14:sldId id="260"/>
           </p14:sldIdLst>
         </p14:section>
-        <p14:section name="Apps" id="{fb89eebb-0141-ac8e-eefe-4e882fe1124e}">
+        <p14:section name="Apps" id="{aecc521e-af11-9df2-e6c9-123b0d81b0b8}">
           <p14:sldIdLst>
             <p14:sldId id="261"/>
             <p14:sldId id="262"/>
@@ -141,7 +141,7 @@
             <p14:sldId id="266"/>
           </p14:sldIdLst>
         </p14:section>
-        <p14:section name="Delivery" id="{f9d8bd25-64b9-0d2f-f536-f9c583d72685}">
+        <p14:section name="Delivery" id="{fcb47493-1a1d-2f0c-e2ad-8209cc96e6f2}">
           <p14:sldIdLst>
             <p14:sldId id="267"/>
           </p14:sldIdLst>
@@ -4252,7 +4252,7 @@
       </p:sp>
       <p:sp>
         <p:nvSpPr>
-          <p:cNvPr id="27" name="module psa-application-ui"/>
+          <p:cNvPr id="27" name="module psa-application"/>
           <p:cNvSpPr/>
           <p:nvPr/>
         </p:nvSpPr>
@@ -4302,7 +4302,7 @@
                   <a:schemeClr val="bg1"/>
                 </a:solidFill>
               </a:rPr>
-              <a:t>psa-application-ui</a:t>
+              <a:t>psa-application</a:t>
             </a:r>
             <a:endParaRPr lang="en-US" sz="1300" dirty="0"/>
           </a:p>

</xml_diff>